<commit_message>
Tighten deck to industrial sources, remove watermark, add talk track
- Swap consumer and software-only stats for industrial and manufacturing
  sources where they exist (Aleran quoting survey, UPS industrial buyers,
  Salesforce manufacturing, GlobalSpec engineers). Label scope on the rest.
- Add a Steel King touchpoint slide mapping each stat to a step in our
  own process (web RFQ, dealer quote, drawings, follow-up, service,
  existing accounts).
- Full spoken talk track in speaker notes and talk-track.md: script,
  expected pushback, and source to cite for every slide.
- New templates/ folder with the Steel King template stripped of the
  shield watermark on all white layouts, plus the script that did it.
  Deck now builds from the repo template.

Co-Authored-By: Claude Fable 5.1 <noreply@anthropic.com>
Claude-Session: https://claude.ai/code/session_01NzWxgpkJGuV4HqEXz4J3r3
</commit_message>
<xml_diff>
--- a/sales-meeting/Speed_and_Service_Win_the_Order.pptx
+++ b/sales-meeting/Speed_and_Service_Win_the_Order.pptx
@@ -29,6 +29,7 @@
     <p:sldId id="277" r:id="rId28"/>
     <p:sldId id="278" r:id="rId29"/>
     <p:sldId id="279" r:id="rId30"/>
+    <p:sldId id="280" r:id="rId31"/>
   </p:sldIdLst>
   <p:notesMasterIdLst>
     <p:notesMasterId r:id="rId17"/>
@@ -870,7 +871,43 @@
           <a:lstStyle/>
           <a:p>
             <a:r>
-              <a:t>Open with the point: buyers pick a favorite before they call. Our first touch and how we support them after decide whether that favorite is Steel King. Everything in this deck is sourced. Widely quoted numbers that could not be traced to a real study were left out on purpose.</a:t>
+              <a:t>SAY</a:t>
+            </a:r>
+          </a:p>
+          <a:p>
+            <a:r>
+              <a:t>This is not a pep talk about customer service. It is what the data says about how warehouse and</a:t>
+            </a:r>
+          </a:p>
+          <a:p>
+            <a:r>
+              <a:t>     industrial buyers pick a rack supplier, and what that means for how fast we answer and how long we stay</a:t>
+            </a:r>
+          </a:p>
+          <a:p>
+            <a:r>
+              <a:t>     on a lead. Every number in here comes from a named study. I will tell you where each one comes from,</a:t>
+            </a:r>
+          </a:p>
+          <a:p>
+            <a:r>
+              <a:t>     and I will tell you which popular numbers I left out because they don't hold up. Fifty minutes. The last</a:t>
+            </a:r>
+          </a:p>
+          <a:p>
+            <a:r>
+              <a:t>     fifteen are ours to decide what we change.</a:t>
+            </a:r>
+          </a:p>
+          <a:p/>
+          <a:p>
+            <a:r>
+              <a:t>SOURCE</a:t>
+            </a:r>
+          </a:p>
+          <a:p>
+            <a:r>
+              <a:t>Companion research brief has every citation, URL, and a confidence grade.</a:t>
             </a:r>
           </a:p>
         </p:txBody>
@@ -940,7 +977,17 @@
           <a:lstStyle/>
           <a:p>
             <a:r>
-              <a:t>Velocify (then Leads360) Dec 2012, 400+ companies, ~3.5M leads, skewed to mortgage, insurance, education: 50% of leads called once; 93% of converted leads reached by the 6th call; 6-call cadence +49%, 5-email +53%, combined +128%; calling within 1 minute +391% conversion. Consumer phone-heavy data, so quote the pattern, not the precision. RAIN Group 2018: average touches to get a meeting with a new account 8 for the field, 5 for top performers; top performers generate 52 conversions per 100 targets vs 19. Buyer tolerance: 2 to 4 contacts 55%, 5 to 10 23%, 11 to 15 12%. InsideSales: 1.3 call attempts average. XANT 2016 audit: average persistence 4.5 touches, only 9.4% got 12 touches. NOT USED: '80% of sales take 5 follow-ups, 44% of reps quit after one.' That traces to a 1942 survey of fewer than 40 salespeople on Long Island and has no modern source.</a:t>
+              <a:t>SAY</a:t>
+            </a:r>
+          </a:p>
+          <a:p>
+            <a:r>
+              <a:t>Now speed. This is the most studied question in sales research, and the answer has not changed in</a:t>
+            </a:r>
+          </a:p>
+          <a:p>
+            <a:r>
+              <a:t>     fifteen years.</a:t>
             </a:r>
           </a:p>
         </p:txBody>
@@ -1010,7 +1057,89 @@
           <a:lstStyle/>
           <a:p>
             <a:r>
-              <a:t>This slide is optional in a short meeting, but it earns trust. If someone quotes one of these at us later, we know where it came from. The companion research brief has the full trace for each.</a:t>
+              <a:t>SAY</a:t>
+            </a:r>
+          </a:p>
+          <a:p>
+            <a:r>
+              <a:t>The cleanest study on this is Harvard Business Review, 2011. Two datasets. First, one and a quarter</a:t>
+            </a:r>
+          </a:p>
+          <a:p>
+            <a:r>
+              <a:t>     million leads at forty-two companies, both B2C and B2B. Companies that tried to reach a lead within an</a:t>
+            </a:r>
+          </a:p>
+          <a:p>
+            <a:r>
+              <a:t>     hour were nearly seven times as likely to qualify it as companies that waited even one more hour.</a:t>
+            </a:r>
+          </a:p>
+          <a:p>
+            <a:r>
+              <a:t>     Compared to companies that waited a day, sixty times. Second, they audited two thousand two hundred</a:t>
+            </a:r>
+          </a:p>
+          <a:p>
+            <a:r>
+              <a:t>     forty-one U.S. companies by submitting a lead and timing the response. Average response, among</a:t>
+            </a:r>
+          </a:p>
+          <a:p>
+            <a:r>
+              <a:t>     companies that responded at all, was forty-two hours. Twenty-three percent never responded. Think about</a:t>
+            </a:r>
+          </a:p>
+          <a:p>
+            <a:r>
+              <a:t>     what forty-two hours means for a rack inquiry. The buyer filled out our form Tuesday morning. We call</a:t>
+            </a:r>
+          </a:p>
+          <a:p>
+            <a:r>
+              <a:t>     back Thursday. In between, they heard from two competitors and maybe a dealer. The lead is not dead,</a:t>
+            </a:r>
+          </a:p>
+          <a:p>
+            <a:r>
+              <a:t>     but it is no longer ours to lose. It is ours to win back.</a:t>
+            </a:r>
+          </a:p>
+          <a:p/>
+          <a:p>
+            <a:r>
+              <a:t>IF ASKED</a:t>
+            </a:r>
+          </a:p>
+          <a:p>
+            <a:r>
+              <a:t>Why not the famous 21x number? That is from a 2007 study sponsored by InsideSales.com, done by an MIT</a:t>
+            </a:r>
+          </a:p>
+          <a:p>
+            <a:r>
+              <a:t>     fellow. It gets called the MIT study. It was never published by MIT. HBR is peer-edited and the</a:t>
+            </a:r>
+          </a:p>
+          <a:p>
+            <a:r>
+              <a:t>     sample is bigger, so I use HBR's 7x and 60x. If someone quotes 47 hours, HBR says 42. The 47 is a</a:t>
+            </a:r>
+          </a:p>
+          <a:p>
+            <a:r>
+              <a:t>     transcription error that has been copied for a decade.</a:t>
+            </a:r>
+          </a:p>
+          <a:p/>
+          <a:p>
+            <a:r>
+              <a:t>SOURCE</a:t>
+            </a:r>
+          </a:p>
+          <a:p>
+            <a:r>
+              <a:t>Oldroyd, McElheran, Elkington, The Short Life of Online Sales Leads, Harvard Business Review, March 2011.</a:t>
             </a:r>
           </a:p>
         </p:txBody>
@@ -1080,7 +1209,94 @@
           <a:lstStyle/>
           <a:p>
             <a:r>
-              <a:t>MMH/Peerless 2026 Automation Study: 'very important' when evaluating: fast service response 95% (from 83%), durability/uptime 92%, purchase price 78%, TCO/ROI 77%, parts availability 74%. 2025 Lift Truck User Survey: service response time is a top-5 purchase factor. Salesforce 7th ed. 2024: reasons customers stopped buying in the past year, poor customer service 43% overall, 41% among business buyers, behind high prices at 65%. Zendesk CX Trends 2025: 63% of consumers willing to switch after one bad experience, up 9% YoY. Consumer sample; use as direction. Microsoft 2019 State of Global Customer Service: 61% have stopped doing business with a brand over poor service; 95% call service important to brand choice. MHEDA Journal, Hytrol CRO: 'response time is within minutes, not hours' for uptime-critical end users.</a:t>
+              <a:t>SAY</a:t>
+            </a:r>
+          </a:p>
+          <a:p>
+            <a:r>
+              <a:t>Has it gotten better since 2011? No. Start with our own industry. A 2025 survey of two hundred U.S.</a:t>
+            </a:r>
+          </a:p>
+          <a:p>
+            <a:r>
+              <a:t>     manufacturers and distributors found seventy-one percent take a day or more to produce a quote, and</a:t>
+            </a:r>
+          </a:p>
+          <a:p>
+            <a:r>
+              <a:t>     eighty-eight percent admit they have lost deals to slow, manual quoting. In March of this year, Workato</a:t>
+            </a:r>
+          </a:p>
+          <a:p>
+            <a:r>
+              <a:t>     sent demo requests to a hundred fourteen B2B companies. One of them sent a personalized reply within</a:t>
+            </a:r>
+          </a:p>
+          <a:p>
+            <a:r>
+              <a:t>     five minutes. Zero called within five minutes. Only thirty-one percent ever called. InsideSales looked</a:t>
+            </a:r>
+          </a:p>
+          <a:p>
+            <a:r>
+              <a:t>     at five point seven million leads across their platform: seventy-seven percent never got a response at</a:t>
+            </a:r>
+          </a:p>
+          <a:p>
+            <a:r>
+              <a:t>     all, and the average rep made one point three call attempts before moving on. The chart is the HBR</a:t>
+            </a:r>
+          </a:p>
+          <a:p>
+            <a:r>
+              <a:t>     audit: thirty-seven percent inside an hour, twenty-three percent never. Here is why this is good news.</a:t>
+            </a:r>
+          </a:p>
+          <a:p>
+            <a:r>
+              <a:t>     Fast response is not table stakes. Almost nobody does it. The bar is on the floor. If we answer a rack</a:t>
+            </a:r>
+          </a:p>
+          <a:p>
+            <a:r>
+              <a:t>     inquiry the same morning, we are already ahead of two thirds of the market.</a:t>
+            </a:r>
+          </a:p>
+          <a:p/>
+          <a:p>
+            <a:r>
+              <a:t>IF ASKED</a:t>
+            </a:r>
+          </a:p>
+          <a:p>
+            <a:r>
+              <a:t>The Aleran survey is sponsored by a quoting-software vendor, so treat the exact percentages with care.</a:t>
+            </a:r>
+          </a:p>
+          <a:p>
+            <a:r>
+              <a:t>     The Workato and InsideSales samples are heavy on software companies. HBR's sample was mixed B2C and</a:t>
+            </a:r>
+          </a:p>
+          <a:p>
+            <a:r>
+              <a:t>     B2B. Every audit, in every industry, for fifteen years, lands in the same place.</a:t>
+            </a:r>
+          </a:p>
+          <a:p/>
+          <a:p>
+            <a:r>
+              <a:t>SOURCE</a:t>
+            </a:r>
+          </a:p>
+          <a:p>
+            <a:r>
+              <a:t>Aleran Built to Sell survey, July 2025, n=200. Workato, What We Learned from 114 Companies, March</a:t>
+            </a:r>
+          </a:p>
+          <a:p>
+            <a:r>
+              <a:t>     2026. InsideSales 2021 Lead Response Management, 5.7M leads. HBR 2011.</a:t>
             </a:r>
           </a:p>
         </p:txBody>
@@ -1150,7 +1366,99 @@
           <a:lstStyle/>
           <a:p>
             <a:r>
-              <a:t>Deloitte 2026 outlook (600 execs): aftermarket margins more than 2x equipment. Gartner May 2025: 73% of CSOs prioritizing existing-customer growth; 57% rank retention/growth top-3. Accenture 2022 (2,030 service leaders, 3,428 B2B customers): service-as-value-center companies 3.5x revenue growth. Accenture Interactive 2019 (748 B2B buyers): 80% switched suppliers at least once in 24 months. Dimensional Research 2013 (Zendesk sponsored, n=1,046): 62% B2B bought more after good service; 66% B2B stopped after bad; 51% B2B avoid vendor 2+ years later. Dated, but the only clean B2B/B2C split. Gallup 2016: 29% fully engaged, 60% indifferent, 11% actively disengaged; fully engaged deliver 50% higher revenue, 34% higher profitability. Rule of thumb, not a study: probability of selling to an existing customer 60 to 70% vs 5 to 20% for a new prospect (Marketing Metrics, 2010).</a:t>
+              <a:t>SAY</a:t>
+            </a:r>
+          </a:p>
+          <a:p>
+            <a:r>
+              <a:t>Speed gets you the first conversation. Persistence gets you the order. Velocify studied three and a</a:t>
+            </a:r>
+          </a:p>
+          <a:p>
+            <a:r>
+              <a:t>     half million leads. Half were called exactly once. Ninety-three percent of the leads that eventually</a:t>
+            </a:r>
+          </a:p>
+          <a:p>
+            <a:r>
+              <a:t>     converted were reached by the sixth call. A six-call cadence lifted conversion forty-nine percent.</a:t>
+            </a:r>
+          </a:p>
+          <a:p>
+            <a:r>
+              <a:t>     Add a five-email sequence and it was one hundred twenty-eight percent combined. Average rep across the</a:t>
+            </a:r>
+          </a:p>
+          <a:p>
+            <a:r>
+              <a:t>     industry makes one point three attempts. RAIN Group asked both buyers and sellers. The average rep</a:t>
+            </a:r>
+          </a:p>
+          <a:p>
+            <a:r>
+              <a:t>     needs eight touches to get a meeting with a new account. Top performers need five, because each of</a:t>
+            </a:r>
+          </a:p>
+          <a:p>
+            <a:r>
+              <a:t>     their touches carries something the buyer can use: a drawing, a lead time, a reference, a code</a:t>
+            </a:r>
+          </a:p>
+          <a:p>
+            <a:r>
+              <a:t>     question answered. And buyers are fine with it. Fifty-five percent said two to four contacts is</a:t>
+            </a:r>
+          </a:p>
+          <a:p>
+            <a:r>
+              <a:t>     reasonable, another twenty-three percent said five to ten. Last line matters. Persistence runs one</a:t>
+            </a:r>
+          </a:p>
+          <a:p>
+            <a:r>
+              <a:t>     direction. We chase the lead. The buyer never has to chase us. That is the Thomasnet quote again.</a:t>
+            </a:r>
+          </a:p>
+          <a:p/>
+          <a:p>
+            <a:r>
+              <a:t>IF ASKED</a:t>
+            </a:r>
+          </a:p>
+          <a:p>
+            <a:r>
+              <a:t>The Velocify data is mortgage, insurance, and education phone sales, not industrial. I am quoting</a:t>
+            </a:r>
+          </a:p>
+          <a:p>
+            <a:r>
+              <a:t>     the pattern, not defending the exact percentages for rack. The RAIN data is B2B and self-reported.</a:t>
+            </a:r>
+          </a:p>
+          <a:p>
+            <a:r>
+              <a:t>     The InsideSales 1.3 attempts is platform data across 8,000 companies. Three different methods, same</a:t>
+            </a:r>
+          </a:p>
+          <a:p>
+            <a:r>
+              <a:t>     shape: most reps stop early, most conversions happen later.</a:t>
+            </a:r>
+          </a:p>
+          <a:p/>
+          <a:p>
+            <a:r>
+              <a:t>SOURCE</a:t>
+            </a:r>
+          </a:p>
+          <a:p>
+            <a:r>
+              <a:t>Velocify/Leads360 Ultimate Contact Strategy, Dec 2012. RAIN Group Top Performance in Sales</a:t>
+            </a:r>
+          </a:p>
+          <a:p>
+            <a:r>
+              <a:t>     Prospecting, 2018. InsideSales 2014 Lead Response Report. Thomasnet 2021.</a:t>
             </a:r>
           </a:p>
         </p:txBody>
@@ -1220,7 +1528,84 @@
           <a:lstStyle/>
           <a:p>
             <a:r>
-              <a:t>MMH 2025 Lift Truck User Survey: 86% of expenditures through dealer channel, under 15% direct. MHEDA Journal 2025 outlook, storage and handling segment: record order intake post-election, customers expecting contractor-like service, direct online purchasing increasing. MHEDA 2026 Business Trends: #3 rising customer expectations and margin pressure; #15 strategic manufacturer-distributor partnerships essential; #11 next-gen buyers shifting to online research and purchase. UPS 2017 (1,500 U.S. industrial buyers): 50% would switch for returns/training/on-site maintenance; 80% would shift to a supplier with a more user-friendly web presence. UPS 2019: 87% of millennial buyers likely to shift business for better post-sales support. Aleran 2025 (200 manufacturers/distributors, vendor-sponsored): 88% have lost deals to slow manual quoting; 71% take a day or more to quote.</a:t>
+              <a:t>SAY</a:t>
+            </a:r>
+          </a:p>
+          <a:p>
+            <a:r>
+              <a:t>One minute on this because some of you have seen these numbers in a training deck or on LinkedIn.</a:t>
+            </a:r>
+          </a:p>
+          <a:p>
+            <a:r>
+              <a:t>     Eighty percent of sales need five follow-ups and forty-four percent of reps quit after one. That</a:t>
+            </a:r>
+          </a:p>
+          <a:p>
+            <a:r>
+              <a:t>     traces to a 1942 survey of fewer than forty door-to-door salesmen on Long Island. Seventy-eight</a:t>
+            </a:r>
+          </a:p>
+          <a:p>
+            <a:r>
+              <a:t>     percent buy from the first responder. Attributed to a survey nobody can find. Thirty-five to fifty</a:t>
+            </a:r>
+          </a:p>
+          <a:p>
+            <a:r>
+              <a:t>     percent go to the first responder. A vendor blog, no study. The MIT study. Vendor-sponsored, never</a:t>
+            </a:r>
+          </a:p>
+          <a:p>
+            <a:r>
+              <a:t>     published by MIT. The dissatisfied customer tells nine to fifteen people. Attributed to a White House</a:t>
+            </a:r>
+          </a:p>
+          <a:p>
+            <a:r>
+              <a:t>     office that never published it. I checked all of them and pulled them. Here is why I care. We are</a:t>
+            </a:r>
+          </a:p>
+          <a:p>
+            <a:r>
+              <a:t>     about to set standards. If the standard rests on a made-up number, the first skeptic who Googles it</a:t>
+            </a:r>
+          </a:p>
+          <a:p>
+            <a:r>
+              <a:t>     wins the argument. Everything on these slides survives that Google search.</a:t>
+            </a:r>
+          </a:p>
+          <a:p/>
+          <a:p>
+            <a:r>
+              <a:t>IF ASKED</a:t>
+            </a:r>
+          </a:p>
+          <a:p>
+            <a:r>
+              <a:t>If this slide feels like a detour, skip it and reference the brief. But if anyone quotes one of these</a:t>
+            </a:r>
+          </a:p>
+          <a:p>
+            <a:r>
+              <a:t>     numbers back at us later, this is the answer.</a:t>
+            </a:r>
+          </a:p>
+          <a:p/>
+          <a:p>
+            <a:r>
+              <a:t>SOURCE</a:t>
+            </a:r>
+          </a:p>
+          <a:p>
+            <a:r>
+              <a:t>Conciergr and Sales &amp; Marketing Executives International trace of the 80%/5-touches claim, 2021.</a:t>
+            </a:r>
+          </a:p>
+          <a:p>
+            <a:r>
+              <a:t>     Full trace for each item in the research brief, section 8.</a:t>
             </a:r>
           </a:p>
         </p:txBody>
@@ -1290,7 +1675,17 @@
           <a:lstStyle/>
           <a:p>
             <a:r>
-              <a:t>These are proposals for discussion. The one-hour target comes from HBR's 7x finding. Six touches comes from Velocify's 93%-by-the-sixth-call and RAIN's 5 to 8 touches. Same-day service comes from MMH's 95% and Thomasnet's 24-hour expectation. Ask the room: what gets in the way of each one today? That is the list we fix.</a:t>
+              <a:t>SAY</a:t>
+            </a:r>
+          </a:p>
+          <a:p>
+            <a:r>
+              <a:t>The PO is not the finish line. Service after the sale is now part of how buyers pick the next</a:t>
+            </a:r>
+          </a:p>
+          <a:p>
+            <a:r>
+              <a:t>     supplier.</a:t>
             </a:r>
           </a:p>
         </p:txBody>
@@ -1360,7 +1755,109 @@
           <a:lstStyle/>
           <a:p>
             <a:r>
-              <a:t>Baseline first. HBR's audit method is simple: submit a lead to ourselves and time the reply. Do it for web, phone, and a dealer inquiry.</a:t>
+              <a:t>SAY</a:t>
+            </a:r>
+          </a:p>
+          <a:p>
+            <a:r>
+              <a:t>Three numbers, and the first one is ours. Modern Materials Handling asks warehouse decision makers</a:t>
+            </a:r>
+          </a:p>
+          <a:p>
+            <a:r>
+              <a:t>     what is very important when they evaluate equipment. In 2026, ninety-five percent said fast service</a:t>
+            </a:r>
+          </a:p>
+          <a:p>
+            <a:r>
+              <a:t>     response times. A year earlier it was eighty-three percent. That is a twelve-point jump in one year,</a:t>
+            </a:r>
+          </a:p>
+          <a:p>
+            <a:r>
+              <a:t>     and it now sits right next to durability and uptime at ninety-two percent. Purchase price was</a:t>
+            </a:r>
+          </a:p>
+          <a:p>
+            <a:r>
+              <a:t>     seventy-eight. Service response outranks price. Second number, Salesforce asked business buyers why</a:t>
+            </a:r>
+          </a:p>
+          <a:p>
+            <a:r>
+              <a:t>     they stopped buying from a brand in the past year. Price was first at sixty-five percent. Poor customer</a:t>
+            </a:r>
+          </a:p>
+          <a:p>
+            <a:r>
+              <a:t>     service was second at forty-one percent. Third, UPS surveyed fifteen hundred U.S. industrial buyers.</a:t>
+            </a:r>
+          </a:p>
+          <a:p>
+            <a:r>
+              <a:t>     Half said they would switch to a supplier that offered better post-sale support: returns, training,</a:t>
+            </a:r>
+          </a:p>
+          <a:p>
+            <a:r>
+              <a:t>     on-site help. Among millennial buyers, who are now the majority of purchasing managers, eighty-seven</a:t>
+            </a:r>
+          </a:p>
+          <a:p>
+            <a:r>
+              <a:t>     percent. For a rack buyer, service is the install crew showing up when promised, the parts desk</a:t>
+            </a:r>
+          </a:p>
+          <a:p>
+            <a:r>
+              <a:t>     answering the same day, and the engineer calling back on a damaged upright. That is the product now.</a:t>
+            </a:r>
+          </a:p>
+          <a:p/>
+          <a:p>
+            <a:r>
+              <a:t>IF ASKED</a:t>
+            </a:r>
+          </a:p>
+          <a:p>
+            <a:r>
+              <a:t>The MMH 2026 study is automation buyers, not rack buyers specifically, but it is the same warehouse</a:t>
+            </a:r>
+          </a:p>
+          <a:p>
+            <a:r>
+              <a:t>     decision maker. The MMH 2025 lift truck survey puts service response time in the top five purchase</a:t>
+            </a:r>
+          </a:p>
+          <a:p>
+            <a:r>
+              <a:t>     factors, and the MHEDA Journal quotes Hytrol's CRO saying response for uptime-critical customers has</a:t>
+            </a:r>
+          </a:p>
+          <a:p>
+            <a:r>
+              <a:t>     to be within minutes, not hours.</a:t>
+            </a:r>
+          </a:p>
+          <a:p/>
+          <a:p>
+            <a:r>
+              <a:t>SOURCE</a:t>
+            </a:r>
+          </a:p>
+          <a:p>
+            <a:r>
+              <a:t>MMH/Peerless 2026 Automation Study (95%, 92%, 78%) and 2025 Automation Survey (83%). Salesforce State</a:t>
+            </a:r>
+          </a:p>
+          <a:p>
+            <a:r>
+              <a:t>     of the AI Connected Customer, 7th ed., 2024, 1,570 business buyers (41%, 65%). UPS Industrial Buying</a:t>
+            </a:r>
+          </a:p>
+          <a:p>
+            <a:r>
+              <a:t>     Dynamics 2017 (50%) and 2019 (87%).</a:t>
             </a:r>
           </a:p>
         </p:txBody>
@@ -1430,7 +1927,119 @@
           <a:lstStyle/>
           <a:p>
             <a:r>
-              <a:t>Close the argument here before the action list.</a:t>
+              <a:t>SAY</a:t>
+            </a:r>
+          </a:p>
+          <a:p>
+            <a:r>
+              <a:t>Left side, what service earns. Deloitte's 2026 manufacturing outlook: aftermarket services carry</a:t>
+            </a:r>
+          </a:p>
+          <a:p>
+            <a:r>
+              <a:t>     margins more than twice what equipment sales carry. Salesforce surveyed eight hundred thirty</a:t>
+            </a:r>
+          </a:p>
+          <a:p>
+            <a:r>
+              <a:t>     manufacturers: ninety-seven percent are changing how they run service and aftermarket, and of the</a:t>
+            </a:r>
+          </a:p>
+          <a:p>
+            <a:r>
+              <a:t>     ones that track satisfaction, only forty-four percent are hitting their goals. So everyone knows it</a:t>
+            </a:r>
+          </a:p>
+          <a:p>
+            <a:r>
+              <a:t>     matters and most are not there yet. Gartner: seventy-three percent of chief sales officers now put</a:t>
+            </a:r>
+          </a:p>
+          <a:p>
+            <a:r>
+              <a:t>     existing-customer growth ahead of new logos. Accenture: companies that treat service as a value center</a:t>
+            </a:r>
+          </a:p>
+          <a:p>
+            <a:r>
+              <a:t>     grow revenue three and a half times faster than companies that treat it as a cost. Right side, what</a:t>
+            </a:r>
+          </a:p>
+          <a:p>
+            <a:r>
+              <a:t>     poor service costs. Eighty percent of frequent B2B buyers switched a supplier in the last two years</a:t>
+            </a:r>
+          </a:p>
+          <a:p>
+            <a:r>
+              <a:t>     because it could not meet expectations. Sixty-six percent of B2B customers stopped buying after one bad</a:t>
+            </a:r>
+          </a:p>
+          <a:p>
+            <a:r>
+              <a:t>     service interaction, and half of those were still avoiding that vendor two years later. Gallup: only</a:t>
+            </a:r>
+          </a:p>
+          <a:p>
+            <a:r>
+              <a:t>     twenty-nine percent of B2B customers are fully engaged. The other seventy-one percent are, in their</a:t>
+            </a:r>
+          </a:p>
+          <a:p>
+            <a:r>
+              <a:t>     words, ready to take their business elsewhere. For us: a rack customer who had a good install and a</a:t>
+            </a:r>
+          </a:p>
+          <a:p>
+            <a:r>
+              <a:t>     fast parts response buys the next building from us without a bid. One who didn't tells the dealer.</a:t>
+            </a:r>
+          </a:p>
+          <a:p/>
+          <a:p>
+            <a:r>
+              <a:t>IF ASKED</a:t>
+            </a:r>
+          </a:p>
+          <a:p>
+            <a:r>
+              <a:t>The 66% and 51% are from 2013, the only study with a clean B2B versus B2C split on service-driven</a:t>
+            </a:r>
+          </a:p>
+          <a:p>
+            <a:r>
+              <a:t>     buying. Gallup is 2016. The rest is 2022 to 2026. The old numbers are flagged as dated in the brief.</a:t>
+            </a:r>
+          </a:p>
+          <a:p>
+            <a:r>
+              <a:t>     The rule of thumb that selling to an existing customer is 60 to 70% likely versus 5 to 20% for a new</a:t>
+            </a:r>
+          </a:p>
+          <a:p>
+            <a:r>
+              <a:t>     prospect is a textbook figure, not a study, so it is not on the slide.</a:t>
+            </a:r>
+          </a:p>
+          <a:p/>
+          <a:p>
+            <a:r>
+              <a:t>SOURCE</a:t>
+            </a:r>
+          </a:p>
+          <a:p>
+            <a:r>
+              <a:t>Deloitte 2026 Manufacturing Industry Outlook. Salesforce Trends in Manufacturing 2024. Gartner CSO</a:t>
+            </a:r>
+          </a:p>
+          <a:p>
+            <a:r>
+              <a:t>     survey, May 2025. Accenture End-to-Endless Customer Service 2022. Accenture Interactive 2019.</a:t>
+            </a:r>
+          </a:p>
+          <a:p>
+            <a:r>
+              <a:t>     Dimensional Research for Zendesk 2013. Gallup Guide to Customer Centricity 2016.</a:t>
             </a:r>
           </a:p>
         </p:txBody>
@@ -1500,7 +2109,99 @@
           <a:lstStyle/>
           <a:p>
             <a:r>
-              <a:t>Owners are placeholders based on role. Confirm names in the room.</a:t>
+              <a:t>SAY</a:t>
+            </a:r>
+          </a:p>
+          <a:p>
+            <a:r>
+              <a:t>Most of what we sell goes through a dealer, so let's talk about the dealer's clock. The best channel</a:t>
+            </a:r>
+          </a:p>
+          <a:p>
+            <a:r>
+              <a:t>     number in material handling is lift trucks: eighty-six percent of spend runs through dealers, under</a:t>
+            </a:r>
+          </a:p>
+          <a:p>
+            <a:r>
+              <a:t>     fifteen percent direct. Nobody publishes the same split for rack, but we know our own mix. MHEDA's 2025</a:t>
+            </a:r>
+          </a:p>
+          <a:p>
+            <a:r>
+              <a:t>     outlook for the storage and handling segment says customers now expect contractor-like service</a:t>
+            </a:r>
+          </a:p>
+          <a:p>
+            <a:r>
+              <a:t>     capabilities from the dealer. Its 2026 trends list has rising customer expectations squeezing dealer</a:t>
+            </a:r>
+          </a:p>
+          <a:p>
+            <a:r>
+              <a:t>     margins, and manufacturer-distributor partnerships becoming essential. Hytrol's chief revenue officer</a:t>
+            </a:r>
+          </a:p>
+          <a:p>
+            <a:r>
+              <a:t>     told MHEDA members that for uptime-critical end users, response has to be within minutes, not hours.</a:t>
+            </a:r>
+          </a:p>
+          <a:p>
+            <a:r>
+              <a:t>     And eighty percent of industrial buyers say they would move to a supplier with a more usable web</a:t>
+            </a:r>
+          </a:p>
+          <a:p>
+            <a:r>
+              <a:t>     presence, which is a marketing item for John and me. Here is the connection. When a dealer sends us a</a:t>
+            </a:r>
+          </a:p>
+          <a:p>
+            <a:r>
+              <a:t>     quote request, a drawing question, or a parts inquiry, there is an end customer on the other side of</a:t>
+            </a:r>
+          </a:p>
+          <a:p>
+            <a:r>
+              <a:t>     that dealer holding the twenty-four-hour clock from slide eight. The dealer cannot be faster than we</a:t>
+            </a:r>
+          </a:p>
+          <a:p>
+            <a:r>
+              <a:t>     are. Our response time is their response time.</a:t>
+            </a:r>
+          </a:p>
+          <a:p/>
+          <a:p>
+            <a:r>
+              <a:t>IF ASKED</a:t>
+            </a:r>
+          </a:p>
+          <a:p>
+            <a:r>
+              <a:t>If someone asks for a rack-specific channel share: it does not exist publicly. MHEDA's distributor</a:t>
+            </a:r>
+          </a:p>
+          <a:p>
+            <a:r>
+              <a:t>     statistics are member-only. Use our own bookings mix.</a:t>
+            </a:r>
+          </a:p>
+          <a:p/>
+          <a:p>
+            <a:r>
+              <a:t>SOURCE</a:t>
+            </a:r>
+          </a:p>
+          <a:p>
+            <a:r>
+              <a:t>MMH/Peerless 2025 Lift Truck User Survey. MHEDA Journal 2025 Industry Outlook. MHEDA 2026 Material</a:t>
+            </a:r>
+          </a:p>
+          <a:p>
+            <a:r>
+              <a:t>     Handling Business Trends. MHEDA Journal, Advancing from Distributor to Integrator. UPS 2017.</a:t>
             </a:r>
           </a:p>
         </p:txBody>
@@ -1570,7 +2271,12 @@
           <a:lstStyle/>
           <a:p>
             <a:r>
-              <a:t>Restate the three standards and the first date. Then stop.</a:t>
+              <a:t>SAY</a:t>
+            </a:r>
+          </a:p>
+          <a:p>
+            <a:r>
+              <a:t>That is the evidence. Now what we do with it. First, where it lands in our own process.</a:t>
             </a:r>
           </a:p>
         </p:txBody>
@@ -1640,7 +2346,760 @@
           <a:lstStyle/>
           <a:p>
             <a:r>
-              <a:t>6sense 2025 Buyer Experience Report (about 4,000 buyers): the first vendor contacted wins roughly 8 in 10 deals, and 94% of buying groups had ranked their preferred vendors before making first contact. HBR 2011 audit of 2,241 U.S. companies: average response to a web lead was 42 hours; 23% never responded.</a:t>
+              <a:t>SAY</a:t>
+            </a:r>
+          </a:p>
+          <a:p>
+            <a:r>
+              <a:t>Here is the whole deck in one line. Buyers do their homework before they call anyone. When they do</a:t>
+            </a:r>
+          </a:p>
+          <a:p>
+            <a:r>
+              <a:t>     call, they already have a favorite, and about eight times out of ten they buy from the first vendor they</a:t>
+            </a:r>
+          </a:p>
+          <a:p>
+            <a:r>
+              <a:t>     reach. So the first touch is not the start of the sale. It is the last chance to stay in it. And the</a:t>
+            </a:r>
+          </a:p>
+          <a:p>
+            <a:r>
+              <a:t>     average company takes almost two days to make that first touch. That gap is the opportunity.</a:t>
+            </a:r>
+          </a:p>
+          <a:p/>
+          <a:p>
+            <a:r>
+              <a:t>IF ASKED</a:t>
+            </a:r>
+          </a:p>
+          <a:p>
+            <a:r>
+              <a:t>If someone says our buyers aren't like software buyers: fair, and I'll show industrial data next to the</a:t>
+            </a:r>
+          </a:p>
+          <a:p>
+            <a:r>
+              <a:t>     cross-industry data all the way through. The pattern is the same in every sample we found.</a:t>
+            </a:r>
+          </a:p>
+          <a:p/>
+          <a:p>
+            <a:r>
+              <a:t>SOURCE</a:t>
+            </a:r>
+          </a:p>
+          <a:p>
+            <a:r>
+              <a:t>6sense 2025 Buyer Experience Report, about 4,000 B2B buyers. HBR 2011 audit of 2,241 U.S. companies.</a:t>
+            </a:r>
+          </a:p>
+        </p:txBody>
+      </p:sp>
+      <p:sp>
+        <p:nvSpPr>
+          <p:cNvPr id="4" name="Slide Number Placeholder 3"/>
+          <p:cNvSpPr>
+            <a:spLocks noGrp="1"/>
+          </p:cNvSpPr>
+          <p:nvPr>
+            <p:ph type="sldNum" idx="5" sz="quarter"/>
+          </p:nvPr>
+        </p:nvSpPr>
+        <p:spPr/>
+      </p:sp>
+    </p:spTree>
+  </p:cSld>
+  <p:clrMapOvr>
+    <a:masterClrMapping/>
+  </p:clrMapOvr>
+</p:notes>
+</file>
+
+<file path=ppt/notesSlides/notesSlide20.xml><?xml version="1.0" encoding="utf-8"?>
+<p:notes xmlns:a="http://schemas.openxmlformats.org/drawingml/2006/main" xmlns:p="http://schemas.openxmlformats.org/presentationml/2006/main" xmlns:r="http://schemas.openxmlformats.org/officeDocument/2006/relationships">
+  <p:cSld>
+    <p:spTree>
+      <p:nvGrpSpPr>
+        <p:cNvPr id="1" name=""/>
+        <p:cNvGrpSpPr/>
+        <p:nvPr/>
+      </p:nvGrpSpPr>
+      <p:grpSpPr>
+        <a:xfrm>
+          <a:off x="0" y="0"/>
+          <a:ext cx="0" cy="0"/>
+          <a:chOff x="0" y="0"/>
+          <a:chExt cx="0" cy="0"/>
+        </a:xfrm>
+      </p:grpSpPr>
+      <p:sp>
+        <p:nvSpPr>
+          <p:cNvPr id="2" name="Slide Image Placeholder 1"/>
+          <p:cNvSpPr>
+            <a:spLocks noGrp="1"/>
+          </p:cNvSpPr>
+          <p:nvPr>
+            <p:ph type="sldImg" idx="2"/>
+          </p:nvPr>
+        </p:nvSpPr>
+        <p:spPr/>
+      </p:sp>
+      <p:sp>
+        <p:nvSpPr>
+          <p:cNvPr id="3" name="Notes Placeholder 2"/>
+          <p:cNvSpPr>
+            <a:spLocks noGrp="1"/>
+          </p:cNvSpPr>
+          <p:nvPr>
+            <p:ph type="body" idx="3" sz="quarter"/>
+          </p:nvPr>
+        </p:nvSpPr>
+        <p:spPr/>
+        <p:txBody>
+          <a:bodyPr/>
+          <a:lstStyle/>
+          <a:p>
+            <a:r>
+              <a:t>SAY</a:t>
+            </a:r>
+          </a:p>
+          <a:p>
+            <a:r>
+              <a:t>Six places this research lands in our building. Web RFQs and contact forms: the buyer expects a</a:t>
+            </a:r>
+          </a:p>
+          <a:p>
+            <a:r>
+              <a:t>     human the same day, and the HBR data says an hour. Dealer quote requests: lead time is the number one</a:t>
+            </a:r>
+          </a:p>
+          <a:p>
+            <a:r>
+              <a:t>     shortlist factor, and most manufacturers take a day or more to quote. If we quote same day, the dealer</a:t>
+            </a:r>
+          </a:p>
+          <a:p>
+            <a:r>
+              <a:t>     wins the shortlist. Application and drawings: buyers trust the vendor's engineers more than anyone, and</a:t>
+            </a:r>
+          </a:p>
+          <a:p>
+            <a:r>
+              <a:t>     a rep in the deal cuts regret in half. Follow-up on open quotes: we chase, they never chase. Install,</a:t>
+            </a:r>
+          </a:p>
+          <a:p>
+            <a:r>
+              <a:t>     parts, and service: ninety-five percent rate response time very important, and poor service is the</a:t>
+            </a:r>
+          </a:p>
+          <a:p>
+            <a:r>
+              <a:t>     second reason buyers leave. Existing accounts: aftermarket margins are double equipment, and most CSOs</a:t>
+            </a:r>
+          </a:p>
+          <a:p>
+            <a:r>
+              <a:t>     are now prioritizing the accounts they already have. I want to hear from you on this one. Which of these</a:t>
+            </a:r>
+          </a:p>
+          <a:p>
+            <a:r>
+              <a:t>     six is our weakest today? Where does a lead or a dealer question sit longest? That is what the baseline</a:t>
+            </a:r>
+          </a:p>
+          <a:p>
+            <a:r>
+              <a:t>     in October will tell us, but you already know.</a:t>
+            </a:r>
+          </a:p>
+          <a:p/>
+          <a:p>
+            <a:r>
+              <a:t>IF ASKED</a:t>
+            </a:r>
+          </a:p>
+          <a:p>
+            <a:r>
+              <a:t>This is a discussion slide. Let it run a few minutes. Write down what the room says the weakest</a:t>
+            </a:r>
+          </a:p>
+          <a:p>
+            <a:r>
+              <a:t>     touchpoint is. It goes into the November standards conversation.</a:t>
+            </a:r>
+          </a:p>
+          <a:p/>
+          <a:p>
+            <a:r>
+              <a:t>SOURCE</a:t>
+            </a:r>
+          </a:p>
+          <a:p>
+            <a:r>
+              <a:t>All sources as cited on the preceding slides.</a:t>
+            </a:r>
+          </a:p>
+        </p:txBody>
+      </p:sp>
+      <p:sp>
+        <p:nvSpPr>
+          <p:cNvPr id="4" name="Slide Number Placeholder 3"/>
+          <p:cNvSpPr>
+            <a:spLocks noGrp="1"/>
+          </p:cNvSpPr>
+          <p:nvPr>
+            <p:ph type="sldNum" idx="5" sz="quarter"/>
+          </p:nvPr>
+        </p:nvSpPr>
+        <p:spPr/>
+      </p:sp>
+    </p:spTree>
+  </p:cSld>
+  <p:clrMapOvr>
+    <a:masterClrMapping/>
+  </p:clrMapOvr>
+</p:notes>
+</file>
+
+<file path=ppt/notesSlides/notesSlide21.xml><?xml version="1.0" encoding="utf-8"?>
+<p:notes xmlns:a="http://schemas.openxmlformats.org/drawingml/2006/main" xmlns:p="http://schemas.openxmlformats.org/presentationml/2006/main" xmlns:r="http://schemas.openxmlformats.org/officeDocument/2006/relationships">
+  <p:cSld>
+    <p:spTree>
+      <p:nvGrpSpPr>
+        <p:cNvPr id="1" name=""/>
+        <p:cNvGrpSpPr/>
+        <p:nvPr/>
+      </p:nvGrpSpPr>
+      <p:grpSpPr>
+        <a:xfrm>
+          <a:off x="0" y="0"/>
+          <a:ext cx="0" cy="0"/>
+          <a:chOff x="0" y="0"/>
+          <a:chExt cx="0" cy="0"/>
+        </a:xfrm>
+      </p:grpSpPr>
+      <p:sp>
+        <p:nvSpPr>
+          <p:cNvPr id="2" name="Slide Image Placeholder 1"/>
+          <p:cNvSpPr>
+            <a:spLocks noGrp="1"/>
+          </p:cNvSpPr>
+          <p:nvPr>
+            <p:ph type="sldImg" idx="2"/>
+          </p:nvPr>
+        </p:nvSpPr>
+        <p:spPr/>
+      </p:sp>
+      <p:sp>
+        <p:nvSpPr>
+          <p:cNvPr id="3" name="Notes Placeholder 2"/>
+          <p:cNvSpPr>
+            <a:spLocks noGrp="1"/>
+          </p:cNvSpPr>
+          <p:nvPr>
+            <p:ph type="body" idx="3" sz="quarter"/>
+          </p:nvPr>
+        </p:nvSpPr>
+        <p:spPr/>
+        <p:txBody>
+          <a:bodyPr/>
+          <a:lstStyle/>
+          <a:p>
+            <a:r>
+              <a:t>SAY</a:t>
+            </a:r>
+          </a:p>
+          <a:p>
+            <a:r>
+              <a:t>Three standards. I am proposing them, not announcing them, and I want the room to push on the</a:t>
+            </a:r>
+          </a:p>
+          <a:p>
+            <a:r>
+              <a:t>     numbers. One: first touch inside one business hour. Every web form, every dealer inquiry, every RFQ</a:t>
+            </a:r>
+          </a:p>
+          <a:p>
+            <a:r>
+              <a:t>     gets a human acknowledgment within the hour and a real answer or quote within twenty-four. That comes</a:t>
+            </a:r>
+          </a:p>
+          <a:p>
+            <a:r>
+              <a:t>     straight from the seven-x finding and Thomasnet's twenty-four-hour expectation. Two: six touches before</a:t>
+            </a:r>
+          </a:p>
+          <a:p>
+            <a:r>
+              <a:t>     we close a lead. Nobody marks a lead dead after one call. Six touches across phone and email over two</a:t>
+            </a:r>
+          </a:p>
+          <a:p>
+            <a:r>
+              <a:t>     weeks, and every touch carries something useful. That is Velocify's ninety-three percent by the sixth</a:t>
+            </a:r>
+          </a:p>
+          <a:p>
+            <a:r>
+              <a:t>     call and RAIN's five to eight touches. Three: same-day service response. Parts, install, post-sale</a:t>
+            </a:r>
+          </a:p>
+          <a:p>
+            <a:r>
+              <a:t>     questions get a same-day reply and a named owner. Dealer questions inside four business hours. That is</a:t>
+            </a:r>
+          </a:p>
+          <a:p>
+            <a:r>
+              <a:t>     the ninety-five percent from MMH and the dealer clock. And all three get reported monthly next to</a:t>
+            </a:r>
+          </a:p>
+          <a:p>
+            <a:r>
+              <a:t>     bookings, because what we don't measure, we don't do. What gets in the way of each of these today?</a:t>
+            </a:r>
+          </a:p>
+          <a:p>
+            <a:r>
+              <a:t>     That is the list we fix.</a:t>
+            </a:r>
+          </a:p>
+          <a:p/>
+          <a:p>
+            <a:r>
+              <a:t>IF ASKED</a:t>
+            </a:r>
+          </a:p>
+          <a:p>
+            <a:r>
+              <a:t>Expected pushback: we don't have the people to answer in an hour. Answer: acknowledgment in an hour</a:t>
+            </a:r>
+          </a:p>
+          <a:p>
+            <a:r>
+              <a:t>     is a text or a two-line email that says who owns it and when they'll have an answer. The quote gets</a:t>
+            </a:r>
+          </a:p>
+          <a:p>
+            <a:r>
+              <a:t>     twenty-four hours. Second pushback: six touches will annoy dealers. Answer: RAIN's buyers said two to</a:t>
+            </a:r>
+          </a:p>
+          <a:p>
+            <a:r>
+              <a:t>     ten contacts is normal. The rule is every touch carries something new.</a:t>
+            </a:r>
+          </a:p>
+          <a:p/>
+          <a:p>
+            <a:r>
+              <a:t>SOURCE</a:t>
+            </a:r>
+          </a:p>
+          <a:p>
+            <a:r>
+              <a:t>HBR 2011 (1 hour). Thomasnet 2021 (24 hours). Velocify 2012 and RAIN 2018 (six touches). MMH 2026</a:t>
+            </a:r>
+          </a:p>
+          <a:p>
+            <a:r>
+              <a:t>     and MHEDA (same-day service).</a:t>
+            </a:r>
+          </a:p>
+        </p:txBody>
+      </p:sp>
+      <p:sp>
+        <p:nvSpPr>
+          <p:cNvPr id="4" name="Slide Number Placeholder 3"/>
+          <p:cNvSpPr>
+            <a:spLocks noGrp="1"/>
+          </p:cNvSpPr>
+          <p:nvPr>
+            <p:ph type="sldNum" idx="5" sz="quarter"/>
+          </p:nvPr>
+        </p:nvSpPr>
+        <p:spPr/>
+      </p:sp>
+    </p:spTree>
+  </p:cSld>
+  <p:clrMapOvr>
+    <a:masterClrMapping/>
+  </p:clrMapOvr>
+</p:notes>
+</file>
+
+<file path=ppt/notesSlides/notesSlide22.xml><?xml version="1.0" encoding="utf-8"?>
+<p:notes xmlns:a="http://schemas.openxmlformats.org/drawingml/2006/main" xmlns:p="http://schemas.openxmlformats.org/presentationml/2006/main" xmlns:r="http://schemas.openxmlformats.org/officeDocument/2006/relationships">
+  <p:cSld>
+    <p:spTree>
+      <p:nvGrpSpPr>
+        <p:cNvPr id="1" name=""/>
+        <p:cNvGrpSpPr/>
+        <p:nvPr/>
+      </p:nvGrpSpPr>
+      <p:grpSpPr>
+        <a:xfrm>
+          <a:off x="0" y="0"/>
+          <a:ext cx="0" cy="0"/>
+          <a:chOff x="0" y="0"/>
+          <a:chExt cx="0" cy="0"/>
+        </a:xfrm>
+      </p:grpSpPr>
+      <p:sp>
+        <p:nvSpPr>
+          <p:cNvPr id="2" name="Slide Image Placeholder 1"/>
+          <p:cNvSpPr>
+            <a:spLocks noGrp="1"/>
+          </p:cNvSpPr>
+          <p:nvPr>
+            <p:ph type="sldImg" idx="2"/>
+          </p:nvPr>
+        </p:nvSpPr>
+        <p:spPr/>
+      </p:sp>
+      <p:sp>
+        <p:nvSpPr>
+          <p:cNvPr id="3" name="Notes Placeholder 2"/>
+          <p:cNvSpPr>
+            <a:spLocks noGrp="1"/>
+          </p:cNvSpPr>
+          <p:nvPr>
+            <p:ph type="body" idx="3" sz="quarter"/>
+          </p:nvPr>
+        </p:nvSpPr>
+        <p:spPr/>
+        <p:txBody>
+          <a:bodyPr/>
+          <a:lstStyle/>
+          <a:p>
+            <a:r>
+              <a:t>SAY</a:t>
+            </a:r>
+          </a:p>
+          <a:p>
+            <a:r>
+              <a:t>Four steps. October, baseline. We pull ninety days of CRM data on time to first touch and touches</a:t>
+            </a:r>
+          </a:p>
+          <a:p>
+            <a:r>
+              <a:t>     per lead, and we secret-shop ourselves the way HBR did: submit a web lead, call the main line, send a</a:t>
+            </a:r>
+          </a:p>
+          <a:p>
+            <a:r>
+              <a:t>     dealer-style RFQ, and time the response. No judgment, just the number. November, we agree the standards</a:t>
+            </a:r>
+          </a:p>
+          <a:p>
+            <a:r>
+              <a:t>     with the baseline in front of us and build the six-touch cadence and templates. December, lead routing</a:t>
+            </a:r>
+          </a:p>
+          <a:p>
+            <a:r>
+              <a:t>     with alerts and a response-time report by rep and by dealer. First quarter, it goes on the sales</a:t>
+            </a:r>
+          </a:p>
+          <a:p>
+            <a:r>
+              <a:t>     scorecard and we review it monthly in L10. I own the baseline and the scorecard. Regional managers own</a:t>
+            </a:r>
+          </a:p>
+          <a:p>
+            <a:r>
+              <a:t>     the cadence. Marketing and inside sales own the tooling.</a:t>
+            </a:r>
+          </a:p>
+          <a:p/>
+          <a:p>
+            <a:r>
+              <a:t>IF ASKED</a:t>
+            </a:r>
+          </a:p>
+          <a:p>
+            <a:r>
+              <a:t>If someone asks why not set the standard now: because we don't know if we are at four hours or forty.</a:t>
+            </a:r>
+          </a:p>
+          <a:p>
+            <a:r>
+              <a:t>     The standard should be a stretch from where we are, not a guess.</a:t>
+            </a:r>
+          </a:p>
+        </p:txBody>
+      </p:sp>
+      <p:sp>
+        <p:nvSpPr>
+          <p:cNvPr id="4" name="Slide Number Placeholder 3"/>
+          <p:cNvSpPr>
+            <a:spLocks noGrp="1"/>
+          </p:cNvSpPr>
+          <p:nvPr>
+            <p:ph type="sldNum" idx="5" sz="quarter"/>
+          </p:nvPr>
+        </p:nvSpPr>
+        <p:spPr/>
+      </p:sp>
+    </p:spTree>
+  </p:cSld>
+  <p:clrMapOvr>
+    <a:masterClrMapping/>
+  </p:clrMapOvr>
+</p:notes>
+</file>
+
+<file path=ppt/notesSlides/notesSlide23.xml><?xml version="1.0" encoding="utf-8"?>
+<p:notes xmlns:a="http://schemas.openxmlformats.org/drawingml/2006/main" xmlns:p="http://schemas.openxmlformats.org/presentationml/2006/main" xmlns:r="http://schemas.openxmlformats.org/officeDocument/2006/relationships">
+  <p:cSld>
+    <p:spTree>
+      <p:nvGrpSpPr>
+        <p:cNvPr id="1" name=""/>
+        <p:cNvGrpSpPr/>
+        <p:nvPr/>
+      </p:nvGrpSpPr>
+      <p:grpSpPr>
+        <a:xfrm>
+          <a:off x="0" y="0"/>
+          <a:ext cx="0" cy="0"/>
+          <a:chOff x="0" y="0"/>
+          <a:chExt cx="0" cy="0"/>
+        </a:xfrm>
+      </p:grpSpPr>
+      <p:sp>
+        <p:nvSpPr>
+          <p:cNvPr id="2" name="Slide Image Placeholder 1"/>
+          <p:cNvSpPr>
+            <a:spLocks noGrp="1"/>
+          </p:cNvSpPr>
+          <p:nvPr>
+            <p:ph type="sldImg" idx="2"/>
+          </p:nvPr>
+        </p:nvSpPr>
+        <p:spPr/>
+      </p:sp>
+      <p:sp>
+        <p:nvSpPr>
+          <p:cNvPr id="3" name="Notes Placeholder 2"/>
+          <p:cNvSpPr>
+            <a:spLocks noGrp="1"/>
+          </p:cNvSpPr>
+          <p:nvPr>
+            <p:ph type="body" idx="3" sz="quarter"/>
+          </p:nvPr>
+        </p:nvSpPr>
+        <p:spPr/>
+        <p:txBody>
+          <a:bodyPr/>
+          <a:lstStyle/>
+          <a:p>
+            <a:r>
+              <a:t>SAY</a:t>
+            </a:r>
+          </a:p>
+          <a:p>
+            <a:r>
+              <a:t>Last thought before the action list. Nobody has ever bought a rack system because we called back</a:t>
+            </a:r>
+          </a:p>
+          <a:p>
+            <a:r>
+              <a:t>     fast. Speed and service do not win the order by themselves. What they do is keep us on the shortlist</a:t>
+            </a:r>
+          </a:p>
+          <a:p>
+            <a:r>
+              <a:t>     long enough for the product, the engineering, and the price to win. And the research says the</a:t>
+            </a:r>
+          </a:p>
+          <a:p>
+            <a:r>
+              <a:t>     shortlist is short, it is built early, and it closes fast. We just have to be on it when it closes.</a:t>
+            </a:r>
+          </a:p>
+        </p:txBody>
+      </p:sp>
+      <p:sp>
+        <p:nvSpPr>
+          <p:cNvPr id="4" name="Slide Number Placeholder 3"/>
+          <p:cNvSpPr>
+            <a:spLocks noGrp="1"/>
+          </p:cNvSpPr>
+          <p:nvPr>
+            <p:ph type="sldNum" idx="5" sz="quarter"/>
+          </p:nvPr>
+        </p:nvSpPr>
+        <p:spPr/>
+      </p:sp>
+    </p:spTree>
+  </p:cSld>
+  <p:clrMapOvr>
+    <a:masterClrMapping/>
+  </p:clrMapOvr>
+</p:notes>
+</file>
+
+<file path=ppt/notesSlides/notesSlide24.xml><?xml version="1.0" encoding="utf-8"?>
+<p:notes xmlns:a="http://schemas.openxmlformats.org/drawingml/2006/main" xmlns:p="http://schemas.openxmlformats.org/presentationml/2006/main" xmlns:r="http://schemas.openxmlformats.org/officeDocument/2006/relationships">
+  <p:cSld>
+    <p:spTree>
+      <p:nvGrpSpPr>
+        <p:cNvPr id="1" name=""/>
+        <p:cNvGrpSpPr/>
+        <p:nvPr/>
+      </p:nvGrpSpPr>
+      <p:grpSpPr>
+        <a:xfrm>
+          <a:off x="0" y="0"/>
+          <a:ext cx="0" cy="0"/>
+          <a:chOff x="0" y="0"/>
+          <a:chExt cx="0" cy="0"/>
+        </a:xfrm>
+      </p:grpSpPr>
+      <p:sp>
+        <p:nvSpPr>
+          <p:cNvPr id="2" name="Slide Image Placeholder 1"/>
+          <p:cNvSpPr>
+            <a:spLocks noGrp="1"/>
+          </p:cNvSpPr>
+          <p:nvPr>
+            <p:ph type="sldImg" idx="2"/>
+          </p:nvPr>
+        </p:nvSpPr>
+        <p:spPr/>
+      </p:sp>
+      <p:sp>
+        <p:nvSpPr>
+          <p:cNvPr id="3" name="Notes Placeholder 2"/>
+          <p:cNvSpPr>
+            <a:spLocks noGrp="1"/>
+          </p:cNvSpPr>
+          <p:nvPr>
+            <p:ph type="body" idx="3" sz="quarter"/>
+          </p:nvPr>
+        </p:nvSpPr>
+        <p:spPr/>
+        <p:txBody>
+          <a:bodyPr/>
+          <a:lstStyle/>
+          <a:p>
+            <a:r>
+              <a:t>SAY</a:t>
+            </a:r>
+          </a:p>
+          <a:p>
+            <a:r>
+              <a:t>Six actions. I take the secret shop and the scorecard. Inside sales pulls the CRM data. Regional</a:t>
+            </a:r>
+          </a:p>
+          <a:p>
+            <a:r>
+              <a:t>     managers draft the cadence. We agree the standards at the November meeting. John and inside sales build</a:t>
+            </a:r>
+          </a:p>
+          <a:p>
+            <a:r>
+              <a:t>     the dashboard by mid-December. Names and dates are proposals. Let's fix them now before we leave.</a:t>
+            </a:r>
+          </a:p>
+          <a:p/>
+          <a:p>
+            <a:r>
+              <a:t>IF ASKED</a:t>
+            </a:r>
+          </a:p>
+          <a:p>
+            <a:r>
+              <a:t>Confirm real names for inside sales lead and regional managers in the room. Adjust dates to the</a:t>
+            </a:r>
+          </a:p>
+          <a:p>
+            <a:r>
+              <a:t>     actual November meeting date.</a:t>
+            </a:r>
+          </a:p>
+        </p:txBody>
+      </p:sp>
+      <p:sp>
+        <p:nvSpPr>
+          <p:cNvPr id="4" name="Slide Number Placeholder 3"/>
+          <p:cNvSpPr>
+            <a:spLocks noGrp="1"/>
+          </p:cNvSpPr>
+          <p:nvPr>
+            <p:ph type="sldNum" idx="5" sz="quarter"/>
+          </p:nvPr>
+        </p:nvSpPr>
+        <p:spPr/>
+      </p:sp>
+    </p:spTree>
+  </p:cSld>
+  <p:clrMapOvr>
+    <a:masterClrMapping/>
+  </p:clrMapOvr>
+</p:notes>
+</file>
+
+<file path=ppt/notesSlides/notesSlide25.xml><?xml version="1.0" encoding="utf-8"?>
+<p:notes xmlns:a="http://schemas.openxmlformats.org/drawingml/2006/main" xmlns:p="http://schemas.openxmlformats.org/presentationml/2006/main" xmlns:r="http://schemas.openxmlformats.org/officeDocument/2006/relationships">
+  <p:cSld>
+    <p:spTree>
+      <p:nvGrpSpPr>
+        <p:cNvPr id="1" name=""/>
+        <p:cNvGrpSpPr/>
+        <p:nvPr/>
+      </p:nvGrpSpPr>
+      <p:grpSpPr>
+        <a:xfrm>
+          <a:off x="0" y="0"/>
+          <a:ext cx="0" cy="0"/>
+          <a:chOff x="0" y="0"/>
+          <a:chExt cx="0" cy="0"/>
+        </a:xfrm>
+      </p:grpSpPr>
+      <p:sp>
+        <p:nvSpPr>
+          <p:cNvPr id="2" name="Slide Image Placeholder 1"/>
+          <p:cNvSpPr>
+            <a:spLocks noGrp="1"/>
+          </p:cNvSpPr>
+          <p:nvPr>
+            <p:ph type="sldImg" idx="2"/>
+          </p:nvPr>
+        </p:nvSpPr>
+        <p:spPr/>
+      </p:sp>
+      <p:sp>
+        <p:nvSpPr>
+          <p:cNvPr id="3" name="Notes Placeholder 2"/>
+          <p:cNvSpPr>
+            <a:spLocks noGrp="1"/>
+          </p:cNvSpPr>
+          <p:nvPr>
+            <p:ph type="body" idx="3" sz="quarter"/>
+          </p:nvPr>
+        </p:nvSpPr>
+        <p:spPr/>
+        <p:txBody>
+          <a:bodyPr/>
+          <a:lstStyle/>
+          <a:p>
+            <a:r>
+              <a:t>SAY</a:t>
+            </a:r>
+          </a:p>
+          <a:p>
+            <a:r>
+              <a:t>Three standards. First touch inside an hour. Six touches before a lead closes. Same-day service</a:t>
+            </a:r>
+          </a:p>
+          <a:p>
+            <a:r>
+              <a:t>     response. Baseline in October. On the scorecard by January. Thanks.</a:t>
             </a:r>
           </a:p>
         </p:txBody>
@@ -1710,7 +3169,27 @@
           <a:lstStyle/>
           <a:p>
             <a:r>
-              <a:t>50 minutes. Leave the last 15 for the standards discussion and owners.</a:t>
+              <a:t>SAY</a:t>
+            </a:r>
+          </a:p>
+          <a:p>
+            <a:r>
+              <a:t>Five parts. First, the demand is there, so this is about share. Second, how the buyer actually</a:t>
+            </a:r>
+          </a:p>
+          <a:p>
+            <a:r>
+              <a:t>     decides. Third, what speed does to a lead. Fourth, what service does after the PO. Fifth, three</a:t>
+            </a:r>
+          </a:p>
+          <a:p>
+            <a:r>
+              <a:t>     standards I want us to agree on and a plan to measure them. Hold questions on the standards until the</a:t>
+            </a:r>
+          </a:p>
+          <a:p>
+            <a:r>
+              <a:t>     end. Everything before that is evidence.</a:t>
             </a:r>
           </a:p>
         </p:txBody>
@@ -1780,7 +3259,12 @@
           <a:lstStyle/>
           <a:p>
             <a:r>
-              <a:t>MMH 2026 Outlook (Jan 2026, n=103): racks and shelving named by 45% as a planned purchase, #1 category. Avg planned spend $541,670, up from under $402,000. MMH 2025 Warehouse/DC Operations Survey: net 80% plan to expand, 33% plan to add square footage (from 25%), avg capex $2.16M. Cushman &amp; Wakefield Q2 2026: vacancy 6.9%, pipeline 305 msf up 18% YoY. CBRE Q2 2026 puts vacancy at 6.5%. MHI/Deloitte 2026: 56% of supply chain leaders increasing tech investment, 52% plan to spend over $1M. Growth pockets: cold storage 2026 pipeline only 5.9M sq ft (lowest since 2020) after record 2025 deliveries; data center component manufacturing drove a 28% YoY jump in large manufacturing leases in Q1 2026 (CBRE). MHEDA 2026 members name data centers and cold storage as top niche growth markets.</a:t>
+              <a:t>SAY</a:t>
+            </a:r>
+          </a:p>
+          <a:p>
+            <a:r>
+              <a:t>Quick market check first, because none of this matters if nobody is buying rack. They are.</a:t>
             </a:r>
           </a:p>
         </p:txBody>
@@ -1850,7 +3334,84 @@
           <a:lstStyle/>
           <a:p>
             <a:r>
-              <a:t>GlobalSpec/TREW 2026: 62% of buying process online before contacting sales (66% for buyers 35 and under). Only 6% prefer never to talk to a salesperson; they contact sales for technical complexity, pricing, and inventory. Thomasnet: 71% vet fewer than five suppliers, 25% vet 5 to 10, 3% more than ten. 6sense 2025: buyers make first contact at 61% of the buying process (down from 69% in 2024), 94% of buying groups had ranked preferred vendors before first contact and bought that favorite 77% of the time. First vendor contacted wins about 8 in 10. Gartner: buyers spend 17% of the purchase process meeting with all suppliers combined; any one rep gets 5 to 6% of that time.</a:t>
+              <a:t>SAY</a:t>
+            </a:r>
+          </a:p>
+          <a:p>
+            <a:r>
+              <a:t>Modern Materials Handling surveys warehouse and DC operators every January on what they plan to</a:t>
+            </a:r>
+          </a:p>
+          <a:p>
+            <a:r>
+              <a:t>     buy. For the second year running, racks and shelving is the number one category. Forty-five percent</a:t>
+            </a:r>
+          </a:p>
+          <a:p>
+            <a:r>
+              <a:t>     say they plan to buy. Average planned spend on equipment and systems jumped from about four hundred</a:t>
+            </a:r>
+          </a:p>
+          <a:p>
+            <a:r>
+              <a:t>     thousand to five hundred forty-two thousand. That is a thirty-five percent increase in one year.</a:t>
+            </a:r>
+          </a:p>
+          <a:p>
+            <a:r>
+              <a:t>     On the real estate side, Cushman and Wakefield has three hundred five million square feet of</a:t>
+            </a:r>
+          </a:p>
+          <a:p>
+            <a:r>
+              <a:t>     industrial space under construction, up eighteen percent year over year and rising four quarters</a:t>
+            </a:r>
+          </a:p>
+          <a:p>
+            <a:r>
+              <a:t>     straight. Every one of those buildings needs storage. The point: demand is not our problem. Share is.</a:t>
+            </a:r>
+          </a:p>
+          <a:p/>
+          <a:p>
+            <a:r>
+              <a:t>IF ASKED</a:t>
+            </a:r>
+          </a:p>
+          <a:p>
+            <a:r>
+              <a:t>Sample sizes are small, about a hundred operators each year, but the survey has run for two decades</a:t>
+            </a:r>
+          </a:p>
+          <a:p>
+            <a:r>
+              <a:t>     and the direction is consistent. MHI's 2026 report backs it: 56% of supply chain leaders are increasing</a:t>
+            </a:r>
+          </a:p>
+          <a:p>
+            <a:r>
+              <a:t>     investment and 52% plan to spend over a million. Cold storage and data center adjacent manufacturing</a:t>
+            </a:r>
+          </a:p>
+          <a:p>
+            <a:r>
+              <a:t>     are the two hottest pockets right now.</a:t>
+            </a:r>
+          </a:p>
+          <a:p/>
+          <a:p>
+            <a:r>
+              <a:t>SOURCE</a:t>
+            </a:r>
+          </a:p>
+          <a:p>
+            <a:r>
+              <a:t>MMH/Peerless 2026 Outlook Survey, Jan 2026, n=103. MMH/Peerless 2025 Outlook, n=110. Cushman &amp;</a:t>
+            </a:r>
+          </a:p>
+          <a:p>
+            <a:r>
+              <a:t>     Wakefield U.S. Industrial MarketBeat, Q2 2026. MHI/Deloitte 2026 Annual Industry Report.</a:t>
             </a:r>
           </a:p>
         </p:txBody>
@@ -1920,7 +3481,17 @@
           <a:lstStyle/>
           <a:p>
             <a:r>
-              <a:t>Chart: Industrial Distribution annual Survey of Distributor Operations, reasons distributors say they earn business (relationships 81%, availability 76%, technical support 66%, delivery time 62%, price 53%). Self-reported by distributors. Thomasnet 2021 survey of 400+ buyers published rankings, not percentages, for the shortlist factors. The 44%-within-24-hours figure is from Thomasnet's Industrial Buyer Search Habits survey; year not disclosed on the page.</a:t>
+              <a:t>SAY</a:t>
+            </a:r>
+          </a:p>
+          <a:p>
+            <a:r>
+              <a:t>Now, how the buyer decides. This is where the industrial data and the broad B2B data say the</a:t>
+            </a:r>
+          </a:p>
+          <a:p>
+            <a:r>
+              <a:t>     same thing.</a:t>
             </a:r>
           </a:p>
         </p:txBody>
@@ -1990,7 +3561,89 @@
           <a:lstStyle/>
           <a:p>
             <a:r>
-              <a:t>Salesforce 2023 (6th ed., 3,300 business buyers): 86%, 84%, 59%, 73%. Gartner B2B Buying Report: high regret 43% self-service digital, 26% rep-led, 21% rep-assisted digital; self-service buyers 1.65x more likely to regret. Gartner 2025 sales survey (n=632): 69% report inconsistencies between website and rep. LinkedIn State of Sales 2021 (400+ buyers): deal killers 48% misleading info, 44% not understanding company, 43% not understanding own product. GlobalSpec 2025: only 6% prefer never to talk to a salesperson.</a:t>
+              <a:t>SAY</a:t>
+            </a:r>
+          </a:p>
+          <a:p>
+            <a:r>
+              <a:t>Three numbers. GlobalSpec surveys a thousand engineers and technical buyers every year. Sixty-two</a:t>
+            </a:r>
+          </a:p>
+          <a:p>
+            <a:r>
+              <a:t>     percent of the buying process is finished online before they contact anyone at the vendor. For buyers</a:t>
+            </a:r>
+          </a:p>
+          <a:p>
+            <a:r>
+              <a:t>     under thirty-five it is sixty-six percent. Thomasnet, the industrial sourcing platform, found seventy-one</a:t>
+            </a:r>
+          </a:p>
+          <a:p>
+            <a:r>
+              <a:t>     percent of industrial buyers look at fewer than five suppliers. Only three percent look at more than ten.</a:t>
+            </a:r>
+          </a:p>
+          <a:p>
+            <a:r>
+              <a:t>     And 6sense surveyed four thousand B2B buyers: ninety-four percent had ranked a favorite before they</a:t>
+            </a:r>
+          </a:p>
+          <a:p>
+            <a:r>
+              <a:t>     contacted anyone, and the first vendor they contacted won about eight times out of ten. Put those</a:t>
+            </a:r>
+          </a:p>
+          <a:p>
+            <a:r>
+              <a:t>     together. The buyer has done the research, the list is short, and the first company that picks up the</a:t>
+            </a:r>
+          </a:p>
+          <a:p>
+            <a:r>
+              <a:t>     phone usually gets the order. If our reply sits for a day, that first company is not us.</a:t>
+            </a:r>
+          </a:p>
+          <a:p/>
+          <a:p>
+            <a:r>
+              <a:t>IF ASKED</a:t>
+            </a:r>
+          </a:p>
+          <a:p>
+            <a:r>
+              <a:t>The 6sense sample skews to technology purchases. The GlobalSpec and Thomasnet samples are engineers</a:t>
+            </a:r>
+          </a:p>
+          <a:p>
+            <a:r>
+              <a:t>     and industrial buyers. I put them side by side on purpose: the industrial buyer is doing the same</a:t>
+            </a:r>
+          </a:p>
+          <a:p>
+            <a:r>
+              <a:t>     thing. Gartner adds that buyers spend only seventeen percent of the process talking to any supplier,</a:t>
+            </a:r>
+          </a:p>
+          <a:p>
+            <a:r>
+              <a:t>     and any one rep gets five or six percent of that time. Every minute of contact has to count.</a:t>
+            </a:r>
+          </a:p>
+          <a:p/>
+          <a:p>
+            <a:r>
+              <a:t>SOURCE</a:t>
+            </a:r>
+          </a:p>
+          <a:p>
+            <a:r>
+              <a:t>GlobalSpec/TREW 2026 State of Marketing to Engineers. Thomasnet Industrial Buyer Habits. 6sense 2025</a:t>
+            </a:r>
+          </a:p>
+          <a:p>
+            <a:r>
+              <a:t>     Buyer Experience Report. Gartner B2B Buying Journey.</a:t>
             </a:r>
           </a:p>
         </p:txBody>
@@ -2060,7 +3713,99 @@
           <a:lstStyle/>
           <a:p>
             <a:r>
-              <a:t>HBR March 2011. Two datasets: (1) 1.25 million leads at 42 companies, 29 B2C and 13 B2B: firms that tried to contact within an hour were nearly 7x as likely to qualify the lead as those that waited even one more hour, and more than 60x as likely as those waiting 24 hours or longer. (2) Audit of 2,241 U.S. companies: 37% responded within an hour, 16% within 1 to 24 hours, 24% took more than 24 hours, 23% never responded. Average 42 hours among those responding within 30 days. The older 2007 InsideSales/Oldroyd study (often mislabeled as an MIT study) found qualification odds drop 21x between a 5-minute and a 30-minute response. That was vendor-sponsored; HBR is the cleaner citation.</a:t>
+              <a:t>SAY</a:t>
+            </a:r>
+          </a:p>
+          <a:p>
+            <a:r>
+              <a:t>This is the industrial buyer specifically. Thomasnet asked four hundred registered industrial buyers</a:t>
+            </a:r>
+          </a:p>
+          <a:p>
+            <a:r>
+              <a:t>     what they weigh when they shortlist a new supplier. Number one was availability and lead time. Price</a:t>
+            </a:r>
+          </a:p>
+          <a:p>
+            <a:r>
+              <a:t>     was second. Quality certs third. Verified company information fourth. They also said they expect an</a:t>
+            </a:r>
+          </a:p>
+          <a:p>
+            <a:r>
+              <a:t>     answer in under twenty-four hours, and forty-four percent said that outright. One buyer put it this</a:t>
+            </a:r>
+          </a:p>
+          <a:p>
+            <a:r>
+              <a:t>     way, and I want you to remember the quote: if I have to follow up twice, I eliminate you from</a:t>
+            </a:r>
+          </a:p>
+          <a:p>
+            <a:r>
+              <a:t>     consideration. Their reasons for rejecting a supplier were slow or no RFQ response, having to chase,</a:t>
+            </a:r>
+          </a:p>
+          <a:p>
+            <a:r>
+              <a:t>     unclear pricing, and stale company information. On the right is the distributor side. Industrial</a:t>
+            </a:r>
+          </a:p>
+          <a:p>
+            <a:r>
+              <a:t>     Distribution asks distributors every year why they win business. Relationships, availability, technical</a:t>
+            </a:r>
+          </a:p>
+          <a:p>
+            <a:r>
+              <a:t>     support, and delivery all beat price. Price is fifth. Our dealers know this. The buyer is telling us</a:t>
+            </a:r>
+          </a:p>
+          <a:p>
+            <a:r>
+              <a:t>     the same thing from the other side.</a:t>
+            </a:r>
+          </a:p>
+          <a:p/>
+          <a:p>
+            <a:r>
+              <a:t>IF ASKED</a:t>
+            </a:r>
+          </a:p>
+          <a:p>
+            <a:r>
+              <a:t>The Thomasnet survey published rankings, not percentages, for the shortlist factors. The chart is</a:t>
+            </a:r>
+          </a:p>
+          <a:p>
+            <a:r>
+              <a:t>     self-reported by distributors, so it is what they believe wins, not what buyers said. The two</a:t>
+            </a:r>
+          </a:p>
+          <a:p>
+            <a:r>
+              <a:t>     sources agree, which is why both are here.</a:t>
+            </a:r>
+          </a:p>
+          <a:p/>
+          <a:p>
+            <a:r>
+              <a:t>SOURCE</a:t>
+            </a:r>
+          </a:p>
+          <a:p>
+            <a:r>
+              <a:t>Thomasnet, What Industrial Buyers Care About Most When Shortlisting New Suppliers, 2021, 400+ buyers.</a:t>
+            </a:r>
+          </a:p>
+          <a:p>
+            <a:r>
+              <a:t>     Thomasnet Industrial Buyer Search Habits survey (44%). Industrial Distribution Survey of Distributor</a:t>
+            </a:r>
+          </a:p>
+          <a:p>
+            <a:r>
+              <a:t>     Operations.</a:t>
             </a:r>
           </a:p>
         </p:txBody>
@@ -2130,7 +3875,104 @@
           <a:lstStyle/>
           <a:p>
             <a:r>
-              <a:t>Chart: HBR 2011 audit of 2,241 companies. Workato March 2026: 114 B2B companies received demo requests. Only 1 sent a personalized email within 5 minutes, none called within 5 minutes; avg personalized email 11h54m; avg phone 14h29m; 31% called at all; about 20% never emailed. InsideSales 2021 (400+ companies, 5.7M leads, 55M activities): under 1% of attempts within 5 minutes, under 15% within the first day, 57% of attempts wait more than a week, 77% of leads not responded to at all. InsideSales 2013 audit of 14,061 companies: 47% did not respond; reps averaged 1.3 call attempts (7,960 companies, 2008 to 2012). Drift 2017 (433 SaaS companies): 7% responded within 5 minutes, 55% had not responded after 5 business days.</a:t>
+              <a:t>SAY</a:t>
+            </a:r>
+          </a:p>
+          <a:p>
+            <a:r>
+              <a:t>The self-serve story gets overplayed. Engineers and technical buyers still want a person. Only six</a:t>
+            </a:r>
+          </a:p>
+          <a:p>
+            <a:r>
+              <a:t>     percent say they never want to talk to a salesperson. They call us for two reasons: the application is</a:t>
+            </a:r>
+          </a:p>
+          <a:p>
+            <a:r>
+              <a:t>     technically complex, or they need pricing and inventory, meaning lead time. Two thirds rate the vendor's</a:t>
+            </a:r>
+          </a:p>
+          <a:p>
+            <a:r>
+              <a:t>     engineers as highly trustworthy. That is our application engineers and our regional managers. Gartner</a:t>
+            </a:r>
+          </a:p>
+          <a:p>
+            <a:r>
+              <a:t>     found something I think about a lot: buyers who purchased self-serve with no rep regretted it forty-three</a:t>
+            </a:r>
+          </a:p>
+          <a:p>
+            <a:r>
+              <a:t>     percent of the time. Buyers who had a rep alongside digital tools regretted it twenty-one percent. A rep</a:t>
+            </a:r>
+          </a:p>
+          <a:p>
+            <a:r>
+              <a:t>     cuts regret in half. Now the right side. Fifty-nine percent of business buyers say most reps don't take</a:t>
+            </a:r>
+          </a:p>
+          <a:p>
+            <a:r>
+              <a:t>     time to understand them. Seventy-three percent say the interaction felt transactional. Sixty-nine percent</a:t>
+            </a:r>
+          </a:p>
+          <a:p>
+            <a:r>
+              <a:t>     found the website and the rep telling them different things. The two deal killers buyers name most:</a:t>
+            </a:r>
+          </a:p>
+          <a:p>
+            <a:r>
+              <a:t>     misleading information on price or product, and not understanding the buyer's company. So the buyer</a:t>
+            </a:r>
+          </a:p>
+          <a:p>
+            <a:r>
+              <a:t>     wants us in the deal. They just want us to show up prepared.</a:t>
+            </a:r>
+          </a:p>
+          <a:p/>
+          <a:p>
+            <a:r>
+              <a:t>IF ASKED</a:t>
+            </a:r>
+          </a:p>
+          <a:p>
+            <a:r>
+              <a:t>The left column mixes industrial and cross-industry sources. The 6%, 47%, 40%, and 66% are engineers</a:t>
+            </a:r>
+          </a:p>
+          <a:p>
+            <a:r>
+              <a:t>     and technical buyers. The 86% and the regret numbers are B2B across industries. The right column is</a:t>
+            </a:r>
+          </a:p>
+          <a:p>
+            <a:r>
+              <a:t>     all cross-industry B2B. Nobody has run the right-column questions on industrial buyers specifically.</a:t>
+            </a:r>
+          </a:p>
+          <a:p/>
+          <a:p>
+            <a:r>
+              <a:t>SOURCE</a:t>
+            </a:r>
+          </a:p>
+          <a:p>
+            <a:r>
+              <a:t>GlobalSpec/TREW 2025 (6%, 47%, 40%) and 2026 (66%). Salesforce State of the Connected Customer 2023,</a:t>
+            </a:r>
+          </a:p>
+          <a:p>
+            <a:r>
+              <a:t>     3,300 business buyers (86%, 59%, 73%). Gartner B2B Buying Report, 2022 buyer survey (21% vs 43%).</a:t>
+            </a:r>
+          </a:p>
+          <a:p>
+            <a:r>
+              <a:t>     Gartner 2025 sales survey via Salesforce (69%). LinkedIn State of Sales 2021 (48%, 44%).</a:t>
             </a:r>
           </a:p>
         </p:txBody>
@@ -2190,15 +4032,9 @@
   <p:cSld name="FULL_VISUAL">
     <p:bg>
       <p:bgPr>
-        <a:blipFill dpi="0" rotWithShape="1">
-          <a:blip r:embed="rId2">
-            <a:lum/>
-          </a:blip>
-          <a:srcRect/>
-          <a:stretch>
-            <a:fillRect/>
-          </a:stretch>
-        </a:blipFill>
+        <a:solidFill>
+          <a:srgbClr val="FFFFFF"/>
+        </a:solidFill>
         <a:effectLst/>
       </p:bgPr>
     </p:bg>
@@ -2556,15 +4392,9 @@
   <p:cSld name="COMPARISON">
     <p:bg>
       <p:bgPr>
-        <a:blipFill dpi="0" rotWithShape="1">
-          <a:blip r:embed="rId2">
-            <a:lum/>
-          </a:blip>
-          <a:srcRect/>
-          <a:stretch>
-            <a:fillRect/>
-          </a:stretch>
-        </a:blipFill>
+        <a:solidFill>
+          <a:srgbClr val="FFFFFF"/>
+        </a:solidFill>
         <a:effectLst/>
       </p:bgPr>
     </p:bg>
@@ -3224,15 +5054,9 @@
   <p:cSld name="TIMELINE">
     <p:bg>
       <p:bgPr>
-        <a:blipFill dpi="0" rotWithShape="1">
-          <a:blip r:embed="rId2">
-            <a:lum/>
-          </a:blip>
-          <a:srcRect/>
-          <a:stretch>
-            <a:fillRect/>
-          </a:stretch>
-        </a:blipFill>
+        <a:solidFill>
+          <a:srgbClr val="FFFFFF"/>
+        </a:solidFill>
         <a:effectLst/>
       </p:bgPr>
     </p:bg>
@@ -4684,15 +6508,9 @@
   <p:cSld name="NEXT_STEPS">
     <p:bg>
       <p:bgPr>
-        <a:blipFill dpi="0" rotWithShape="1">
-          <a:blip r:embed="rId2">
-            <a:lum/>
-          </a:blip>
-          <a:srcRect/>
-          <a:stretch>
-            <a:fillRect/>
-          </a:stretch>
-        </a:blipFill>
+        <a:solidFill>
+          <a:srgbClr val="FFFFFF"/>
+        </a:solidFill>
         <a:effectLst/>
       </p:bgPr>
     </p:bg>
@@ -6152,15 +7970,9 @@
   <p:cSld name="AGENDA">
     <p:bg>
       <p:bgPr>
-        <a:blipFill dpi="0" rotWithShape="1">
-          <a:blip r:embed="rId2">
-            <a:lum/>
-          </a:blip>
-          <a:srcRect/>
-          <a:stretch>
-            <a:fillRect/>
-          </a:stretch>
-        </a:blipFill>
+        <a:solidFill>
+          <a:srgbClr val="FFFFFF"/>
+        </a:solidFill>
         <a:effectLst/>
       </p:bgPr>
     </p:bg>
@@ -7262,15 +9074,9 @@
   <p:cSld name="TITLE_CONTENT">
     <p:bg>
       <p:bgPr>
-        <a:blipFill dpi="0" rotWithShape="1">
-          <a:blip r:embed="rId2">
-            <a:lum/>
-          </a:blip>
-          <a:srcRect/>
-          <a:stretch>
-            <a:fillRect/>
-          </a:stretch>
-        </a:blipFill>
+        <a:solidFill>
+          <a:srgbClr val="FFFFFF"/>
+        </a:solidFill>
         <a:effectLst/>
       </p:bgPr>
     </p:bg>
@@ -7638,15 +9444,9 @@
   <p:cSld name="TWO_CONTENT">
     <p:bg>
       <p:bgPr>
-        <a:blipFill dpi="0" rotWithShape="1">
-          <a:blip r:embed="rId2">
-            <a:lum/>
-          </a:blip>
-          <a:srcRect/>
-          <a:stretch>
-            <a:fillRect/>
-          </a:stretch>
-        </a:blipFill>
+        <a:solidFill>
+          <a:srgbClr val="FFFFFF"/>
+        </a:solidFill>
         <a:effectLst/>
       </p:bgPr>
     </p:bg>
@@ -8219,15 +10019,9 @@
   <p:cSld name="THREE_CARDS">
     <p:bg>
       <p:bgPr>
-        <a:blipFill dpi="0" rotWithShape="1">
-          <a:blip r:embed="rId2">
-            <a:lum/>
-          </a:blip>
-          <a:srcRect/>
-          <a:stretch>
-            <a:fillRect/>
-          </a:stretch>
-        </a:blipFill>
+        <a:solidFill>
+          <a:srgbClr val="FFFFFF"/>
+        </a:solidFill>
         <a:effectLst/>
       </p:bgPr>
     </p:bg>
@@ -9097,15 +10891,9 @@
   <p:cSld name="BIG_NUMBERS">
     <p:bg>
       <p:bgPr>
-        <a:blipFill dpi="0" rotWithShape="1">
-          <a:blip r:embed="rId2">
-            <a:lum/>
-          </a:blip>
-          <a:srcRect/>
-          <a:stretch>
-            <a:fillRect/>
-          </a:stretch>
-        </a:blipFill>
+        <a:solidFill>
+          <a:srgbClr val="FFFFFF"/>
+        </a:solidFill>
         <a:effectLst/>
       </p:bgPr>
     </p:bg>
@@ -10019,15 +11807,9 @@
   <p:cSld name="CONTENT_VISUAL">
     <p:bg>
       <p:bgPr>
-        <a:blipFill dpi="0" rotWithShape="1">
-          <a:blip r:embed="rId2">
-            <a:lum/>
-          </a:blip>
-          <a:srcRect/>
-          <a:stretch>
-            <a:fillRect/>
-          </a:stretch>
-        </a:blipFill>
+        <a:solidFill>
+          <a:srgbClr val="FFFFFF"/>
+        </a:solidFill>
         <a:effectLst/>
       </p:bgPr>
     </p:bg>
@@ -11362,7 +13144,7 @@
               </a:spcAft>
             </a:pPr>
             <a:r>
-              <a:t>2026, 114 B2B companies tested: one sent a personalized reply within five minutes. None called within five minutes.</a:t>
+              <a:t>Manufacturers and distributors: 71% take a day or more to produce a quote. 88% say they have lost deals to slow, manual quoting.</a:t>
             </a:r>
           </a:p>
           <a:p>
@@ -11372,7 +13154,7 @@
               </a:spcAft>
             </a:pPr>
             <a:r>
-              <a:t>Average personalized email took 12 hours. Average phone call took 14.5 hours. Only 31% called at all.</a:t>
+              <a:t>2026 test of 114 B2B companies: one sent a personalized reply within five minutes. None called within five minutes. Only 31% called at all.</a:t>
             </a:r>
           </a:p>
           <a:p>
@@ -11382,17 +13164,7 @@
               </a:spcAft>
             </a:pPr>
             <a:r>
-              <a:t>Platform data, 5.7M leads: fewer than 1% of first attempts happen inside five minutes. 77% of leads got no response.</a:t>
-            </a:r>
-          </a:p>
-          <a:p>
-            <a:pPr>
-              <a:spcAft>
-                <a:spcPts val="700"/>
-              </a:spcAft>
-            </a:pPr>
-            <a:r>
-              <a:t>Reps average 1.3 call attempts before giving up.</a:t>
+              <a:t>Platform data across 5.7M leads: 77% of leads never got a response. Reps average 1.3 call attempts before giving up.</a:t>
             </a:r>
           </a:p>
         </p:txBody>
@@ -11413,7 +13185,7 @@
           <a:lstStyle/>
           <a:p>
             <a:r>
-              <a:t>Source: HBR 2011 audit (2,241 companies); Workato lead response study, March 2026 (114 B2B companies); InsideSales 2021 Lead Response Management (5.7M leads).</a:t>
+              <a:t>Source: Aleran survey of 200 U.S. manufacturers and distributors, July 2025 (vendor-sponsored); Workato lead response study, March 2026 (114 B2B companies); InsideSales 2021 Lead Response Management (5.7M leads); HBR 2011 audit.</a:t>
             </a:r>
           </a:p>
         </p:txBody>
@@ -11588,7 +13360,7 @@
               </a:spcAft>
             </a:pPr>
             <a:r>
-              <a:t>Caveat: the Velocify data is consumer phone sales. The direction holds in B2B; the exact percentages are not ours to claim.</a:t>
+              <a:t>Persistence runs one direction. We chase the lead. The buyer never chases us: "If I have to follow up twice, I eliminate you."</a:t>
             </a:r>
           </a:p>
         </p:txBody>
@@ -11609,7 +13381,7 @@
           <a:lstStyle/>
           <a:p>
             <a:r>
-              <a:t>Source: Velocify / Leads360 Ultimate Contact Strategy 2012 (3.5M leads, consumer-heavy verticals); RAIN Group, Top Performance in Sales Prospecting, 2018 (488 buyers, 489 sellers); InsideSales 2013 Lead Response Report.</a:t>
+              <a:t>Source: Velocify / Leads360 Ultimate Contact Strategy 2012 (3.5M leads, consumer-heavy verticals); RAIN Group, Top Performance in Sales Prospecting, 2018 (488 buyers, 489 sellers); InsideSales 2013 Lead Response Report; Thomasnet 2021.</a:t>
             </a:r>
           </a:p>
         </p:txBody>
@@ -11949,7 +13721,7 @@
           <a:lstStyle/>
           <a:p>
             <a:r>
-              <a:t>Buyers rank fast service response next to uptime. Poor service is the second reason business buyers leave.</a:t>
+              <a:t>Fast service response now ranks next to uptime. Poor service is the #2 reason buyers leave.</a:t>
             </a:r>
           </a:p>
         </p:txBody>
@@ -12096,7 +13868,7 @@
           <a:lstStyle/>
           <a:p>
             <a:r>
-              <a:t>63%</a:t>
+              <a:t>50%</a:t>
             </a:r>
           </a:p>
         </p:txBody>
@@ -12117,7 +13889,7 @@
           <a:lstStyle/>
           <a:p>
             <a:r>
-              <a:t>WILL SWITCH AFTER ONE BAD EXPERIENCE</a:t>
+              <a:t>WOULD SWITCH FOR BETTER POST-SALE SUPPORT</a:t>
             </a:r>
           </a:p>
         </p:txBody>
@@ -12138,7 +13910,7 @@
           <a:lstStyle/>
           <a:p>
             <a:r>
-              <a:t>Up nine points year over year</a:t>
+              <a:t>U.S. industrial buyers; 87% of millennial buyers say so</a:t>
             </a:r>
           </a:p>
         </p:txBody>
@@ -12180,7 +13952,7 @@
           <a:lstStyle/>
           <a:p>
             <a:r>
-              <a:t>Source: Modern Materials Handling / Peerless 2026 Automation Study (120+ decision makers) and 2025 Automation Survey (n=139); Salesforce State of the AI Connected Customer 2024 (1,570 business buyers); Zendesk CX Trends 2025 (5,100 consumers).</a:t>
+              <a:t>Source: Modern Materials Handling / Peerless 2026 Automation Study (120+ decision makers) and 2025 Automation Survey (n=139); Salesforce State of the AI Connected Customer 2024 (1,570 business buyers); UPS Industrial Buying Dynamics 2017 (1,500 U.S. buyers) and 2019.</a:t>
             </a:r>
           </a:p>
         </p:txBody>
@@ -12318,7 +14090,7 @@
               </a:spcAft>
             </a:pPr>
             <a:r>
-              <a:t>73% of chief sales officers now prioritize growth from existing customers over new logos.</a:t>
+              <a:t>97% of manufacturers are changing their service and aftermarket operations. Of those tracking satisfaction, only 44% are hitting their goals.</a:t>
             </a:r>
           </a:p>
           <a:p>
@@ -12328,7 +14100,7 @@
               </a:spcAft>
             </a:pPr>
             <a:r>
-              <a:t>Companies that run service as a value center grow revenue 3.5x faster than those that run it as a cost center.</a:t>
+              <a:t>73% of chief sales officers now prioritize growth from existing customers over new logos.</a:t>
             </a:r>
           </a:p>
           <a:p>
@@ -12338,7 +14110,7 @@
               </a:spcAft>
             </a:pPr>
             <a:r>
-              <a:t>62% of B2B customers bought more after a good service experience.</a:t>
+              <a:t>Companies that run service as a value center grow revenue 3.5x faster than those that run it as a cost center.</a:t>
             </a:r>
           </a:p>
         </p:txBody>
@@ -12436,7 +14208,7 @@
           <a:lstStyle/>
           <a:p>
             <a:r>
-              <a:t>Source: Deloitte 2026 Manufacturing Industry Outlook; Gartner CSO survey May 2025 (n=243); Accenture 2022 and 2019 B2B studies; Dimensional Research 2013 (n=1,046, B2B split); Gallup 2016.</a:t>
+              <a:t>Source: Deloitte 2026 Manufacturing Industry Outlook (n=600); Salesforce Trends in Manufacturing 2024 (n=830); Gartner CSO survey May 2025 (n=243); Accenture 2022 and 2019 B2B studies; Dimensional Research 2013 (n=1,046, B2B split); Gallup 2016.</a:t>
             </a:r>
           </a:p>
         </p:txBody>
@@ -12573,7 +14345,7 @@
               </a:spcAft>
             </a:pPr>
             <a:r>
-              <a:t>Half of industrial buyers would switch to a supplier offering returns help, training, and on-site support. 87% of millennial buyers would.</a:t>
+              <a:t>Hytrol's CRO to MHEDA members: for uptime-critical end users, response time has to be "within minutes, not hours."</a:t>
             </a:r>
           </a:p>
           <a:p>
@@ -12583,7 +14355,7 @@
               </a:spcAft>
             </a:pPr>
             <a:r>
-              <a:t>Younger buyers research online and expect to buy online. 80% would move to a supplier with a more usable web presence.</a:t>
+              <a:t>Younger buyers research online and expect to buy online. 80% of industrial buyers would move to a supplier with a more usable web presence.</a:t>
             </a:r>
           </a:p>
           <a:p>
@@ -12614,7 +14386,7 @@
           <a:lstStyle/>
           <a:p>
             <a:r>
-              <a:t>Source: MMH / Peerless 2025 Lift Truck User Survey (n=150); MHEDA Journal 2025 Industry Outlook and 2026 Business Trends; UPS Industrial Buying Dynamics 2017 (1,500 U.S. buyers) and 2019.</a:t>
+              <a:t>Source: MMH / Peerless 2025 Lift Truck User Survey (n=150); MHEDA Journal 2025 Industry Outlook, 2026 Business Trends, and "Advancing from Distributor to Integrator"; UPS Industrial Buying Dynamics 2017 (1,500 U.S. buyers).</a:t>
             </a:r>
           </a:p>
         </p:txBody>
@@ -12815,7 +14587,7 @@
           <a:lstStyle/>
           <a:p>
             <a:r>
-              <a:t>STANDARDS</a:t>
+              <a:t>AT STEEL KING</a:t>
             </a:r>
           </a:p>
         </p:txBody>
@@ -12836,7 +14608,7 @@
           <a:lstStyle/>
           <a:p>
             <a:r>
-              <a:t>Three standards we hold ourselves to</a:t>
+              <a:t>Where this shows up in our own process</a:t>
             </a:r>
           </a:p>
         </p:txBody>
@@ -12857,28 +14629,7 @@
           <a:lstStyle/>
           <a:p>
             <a:r>
-              <a:t>Each one maps to a number in this deck. Each one gets measured.</a:t>
-            </a:r>
-          </a:p>
-        </p:txBody>
-      </p:sp>
-      <p:sp>
-        <p:nvSpPr>
-          <p:cNvPr id="5" name="Text Placeholder 4"/>
-          <p:cNvSpPr>
-            <a:spLocks noGrp="1"/>
-          </p:cNvSpPr>
-          <p:nvPr>
-            <p:ph type="body" idx="106"/>
-          </p:nvPr>
-        </p:nvSpPr>
-        <p:spPr/>
-        <p:txBody>
-          <a:bodyPr/>
-          <a:lstStyle/>
-          <a:p>
-            <a:r>
-              <a:t>1. First touch inside one hour</a:t>
+              <a:t>Six touchpoints we control. Each has a number behind it.</a:t>
             </a:r>
           </a:p>
         </p:txBody>
@@ -12890,125 +14641,678 @@
             <a:spLocks noGrp="1"/>
           </p:cNvSpPr>
           <p:nvPr>
-            <p:ph type="body" idx="107"/>
-          </p:nvPr>
-        </p:nvSpPr>
-        <p:spPr/>
-        <p:txBody>
-          <a:bodyPr/>
-          <a:lstStyle/>
-          <a:p>
-            <a:r>
-              <a:t>Every inbound lead, web form, dealer inquiry, and RFQ gets a human acknowledgment within one business hour. A real answer or quote inside 24 hours. Nobody waits two days to hear from Steel King.</a:t>
-            </a:r>
-          </a:p>
-        </p:txBody>
-      </p:sp>
-      <p:sp>
-        <p:nvSpPr>
-          <p:cNvPr id="7" name="Text Placeholder 6"/>
-          <p:cNvSpPr>
-            <a:spLocks noGrp="1"/>
-          </p:cNvSpPr>
-          <p:nvPr>
-            <p:ph type="body" idx="111"/>
-          </p:nvPr>
-        </p:nvSpPr>
-        <p:spPr/>
-        <p:txBody>
-          <a:bodyPr/>
-          <a:lstStyle/>
-          <a:p>
-            <a:r>
-              <a:t>2. Six touches before we close a lead</a:t>
-            </a:r>
-          </a:p>
-        </p:txBody>
-      </p:sp>
-      <p:sp>
-        <p:nvSpPr>
-          <p:cNvPr id="8" name="Text Placeholder 7"/>
-          <p:cNvSpPr>
-            <a:spLocks noGrp="1"/>
-          </p:cNvSpPr>
-          <p:nvPr>
-            <p:ph type="body" idx="112"/>
-          </p:nvPr>
-        </p:nvSpPr>
-        <p:spPr/>
-        <p:txBody>
-          <a:bodyPr/>
-          <a:lstStyle/>
-          <a:p>
-            <a:r>
-              <a:t>No lead is marked dead after one call. Minimum six touches across phone and email over two weeks, each with something useful: a drawing, a lead time, a reference. Log every touch.</a:t>
-            </a:r>
-          </a:p>
-        </p:txBody>
-      </p:sp>
-      <p:sp>
-        <p:nvSpPr>
-          <p:cNvPr id="9" name="Text Placeholder 8"/>
-          <p:cNvSpPr>
-            <a:spLocks noGrp="1"/>
-          </p:cNvSpPr>
-          <p:nvPr>
-            <p:ph type="body" idx="116"/>
-          </p:nvPr>
-        </p:nvSpPr>
-        <p:spPr/>
-        <p:txBody>
-          <a:bodyPr/>
-          <a:lstStyle/>
-          <a:p>
-            <a:r>
-              <a:t>3. Same-day service response</a:t>
-            </a:r>
-          </a:p>
-        </p:txBody>
-      </p:sp>
-      <p:sp>
-        <p:nvSpPr>
-          <p:cNvPr id="10" name="Text Placeholder 9"/>
-          <p:cNvSpPr>
-            <a:spLocks noGrp="1"/>
-          </p:cNvSpPr>
-          <p:nvPr>
-            <p:ph type="body" idx="117"/>
-          </p:nvPr>
-        </p:nvSpPr>
-        <p:spPr/>
-        <p:txBody>
-          <a:bodyPr/>
-          <a:lstStyle/>
-          <a:p>
-            <a:r>
-              <a:t>Post-sale questions, parts, and install issues get a same-day reply and a named owner. Dealer questions answered within four business hours. Response time reported monthly next to bookings.</a:t>
-            </a:r>
-          </a:p>
-        </p:txBody>
-      </p:sp>
-      <p:sp>
-        <p:nvSpPr>
-          <p:cNvPr id="11" name="Text Placeholder 10"/>
-          <p:cNvSpPr>
-            <a:spLocks noGrp="1"/>
-          </p:cNvSpPr>
-          <p:nvPr>
-            <p:ph type="body" idx="118"/>
-          </p:nvPr>
-        </p:nvSpPr>
-        <p:spPr/>
-        <p:txBody>
-          <a:bodyPr/>
-          <a:lstStyle/>
-          <a:p>
-            <a:r>
-              <a:t>Source: Proposed. Targets set from the research above; final numbers to be confirmed with the team.</a:t>
-            </a:r>
-          </a:p>
-        </p:txBody>
-      </p:sp>
+            <p:ph type="body" idx="104"/>
+          </p:nvPr>
+        </p:nvSpPr>
+        <p:spPr/>
+        <p:txBody>
+          <a:bodyPr/>
+          <a:lstStyle/>
+          <a:p>
+            <a:r>
+              <a:t>Source: Sources as cited on the slides above.</a:t>
+            </a:r>
+          </a:p>
+        </p:txBody>
+      </p:sp>
+      <p:graphicFrame>
+        <p:nvGraphicFramePr>
+          <p:cNvPr id="7" name="Table 6"/>
+          <p:cNvGraphicFramePr>
+            <a:graphicFrameLocks noGrp="1"/>
+          </p:cNvGraphicFramePr>
+          <p:nvPr/>
+        </p:nvGraphicFramePr>
+        <p:xfrm>
+          <a:off x="731520" y="2121408"/>
+          <a:ext cx="10725912" cy="3840480"/>
+        </p:xfrm>
+        <a:graphic>
+          <a:graphicData uri="http://schemas.openxmlformats.org/drawingml/2006/table">
+            <a:tbl>
+              <a:tblPr firstRow="1" bandRow="1">
+                <a:tableStyleId>{5C22544A-7EE6-4342-B048-85BDC9FD1C3A}</a:tableStyleId>
+              </a:tblPr>
+              <a:tblGrid>
+                <a:gridCol w="1920240"/>
+                <a:gridCol w="2788920"/>
+                <a:gridCol w="4279392"/>
+                <a:gridCol w="1737360"/>
+              </a:tblGrid>
+              <a:tr h="548640">
+                <a:tc>
+                  <a:txBody>
+                    <a:bodyPr/>
+                    <a:lstStyle/>
+                    <a:p>
+                      <a:r>
+                        <a:rPr sz="1100" b="1">
+                          <a:solidFill>
+                            <a:srgbClr val="FFFFFF"/>
+                          </a:solidFill>
+                          <a:latin typeface="Arial"/>
+                        </a:rPr>
+                        <a:t>Touchpoint</a:t>
+                      </a:r>
+                    </a:p>
+                  </a:txBody>
+                  <a:tcPr marL="73152" marR="73152" marT="36576" marB="36576">
+                    <a:solidFill>
+                      <a:srgbClr val="3C7D4D"/>
+                    </a:solidFill>
+                  </a:tcPr>
+                </a:tc>
+                <a:tc>
+                  <a:txBody>
+                    <a:bodyPr/>
+                    <a:lstStyle/>
+                    <a:p>
+                      <a:r>
+                        <a:rPr sz="1100" b="1">
+                          <a:solidFill>
+                            <a:srgbClr val="FFFFFF"/>
+                          </a:solidFill>
+                          <a:latin typeface="Arial"/>
+                        </a:rPr>
+                        <a:t>What the buyer expects</a:t>
+                      </a:r>
+                    </a:p>
+                  </a:txBody>
+                  <a:tcPr marL="73152" marR="73152" marT="36576" marB="36576">
+                    <a:solidFill>
+                      <a:srgbClr val="3C7D4D"/>
+                    </a:solidFill>
+                  </a:tcPr>
+                </a:tc>
+                <a:tc>
+                  <a:txBody>
+                    <a:bodyPr/>
+                    <a:lstStyle/>
+                    <a:p>
+                      <a:r>
+                        <a:rPr sz="1100" b="1">
+                          <a:solidFill>
+                            <a:srgbClr val="FFFFFF"/>
+                          </a:solidFill>
+                          <a:latin typeface="Arial"/>
+                        </a:rPr>
+                        <a:t>The number behind it</a:t>
+                      </a:r>
+                    </a:p>
+                  </a:txBody>
+                  <a:tcPr marL="73152" marR="73152" marT="36576" marB="36576">
+                    <a:solidFill>
+                      <a:srgbClr val="3C7D4D"/>
+                    </a:solidFill>
+                  </a:tcPr>
+                </a:tc>
+                <a:tc>
+                  <a:txBody>
+                    <a:bodyPr/>
+                    <a:lstStyle/>
+                    <a:p>
+                      <a:r>
+                        <a:rPr sz="1100" b="1">
+                          <a:solidFill>
+                            <a:srgbClr val="FFFFFF"/>
+                          </a:solidFill>
+                          <a:latin typeface="Arial"/>
+                        </a:rPr>
+                        <a:t>Source</a:t>
+                      </a:r>
+                    </a:p>
+                  </a:txBody>
+                  <a:tcPr marL="73152" marR="73152" marT="36576" marB="36576">
+                    <a:solidFill>
+                      <a:srgbClr val="3C7D4D"/>
+                    </a:solidFill>
+                  </a:tcPr>
+                </a:tc>
+              </a:tr>
+              <a:tr h="548640">
+                <a:tc>
+                  <a:txBody>
+                    <a:bodyPr/>
+                    <a:lstStyle/>
+                    <a:p>
+                      <a:r>
+                        <a:rPr sz="1100" b="0">
+                          <a:solidFill>
+                            <a:srgbClr val="15181A"/>
+                          </a:solidFill>
+                          <a:latin typeface="Arial"/>
+                        </a:rPr>
+                        <a:t>Web RFQ or contact form</a:t>
+                      </a:r>
+                    </a:p>
+                  </a:txBody>
+                  <a:tcPr marL="73152" marR="73152" marT="36576" marB="36576">
+                    <a:solidFill>
+                      <a:srgbClr val="FFFFFF"/>
+                    </a:solidFill>
+                  </a:tcPr>
+                </a:tc>
+                <a:tc>
+                  <a:txBody>
+                    <a:bodyPr/>
+                    <a:lstStyle/>
+                    <a:p>
+                      <a:r>
+                        <a:rPr sz="1100" b="0">
+                          <a:solidFill>
+                            <a:srgbClr val="15181A"/>
+                          </a:solidFill>
+                          <a:latin typeface="Arial"/>
+                        </a:rPr>
+                        <a:t>A human reply the same day</a:t>
+                      </a:r>
+                    </a:p>
+                  </a:txBody>
+                  <a:tcPr marL="73152" marR="73152" marT="36576" marB="36576">
+                    <a:solidFill>
+                      <a:srgbClr val="FFFFFF"/>
+                    </a:solidFill>
+                  </a:tcPr>
+                </a:tc>
+                <a:tc>
+                  <a:txBody>
+                    <a:bodyPr/>
+                    <a:lstStyle/>
+                    <a:p>
+                      <a:r>
+                        <a:rPr sz="1100" b="0">
+                          <a:solidFill>
+                            <a:srgbClr val="15181A"/>
+                          </a:solidFill>
+                          <a:latin typeface="Arial"/>
+                        </a:rPr>
+                        <a:t>7x more likely to qualify inside an hour. 44% expect an answer within 24 hours.</a:t>
+                      </a:r>
+                    </a:p>
+                  </a:txBody>
+                  <a:tcPr marL="73152" marR="73152" marT="36576" marB="36576">
+                    <a:solidFill>
+                      <a:srgbClr val="FFFFFF"/>
+                    </a:solidFill>
+                  </a:tcPr>
+                </a:tc>
+                <a:tc>
+                  <a:txBody>
+                    <a:bodyPr/>
+                    <a:lstStyle/>
+                    <a:p>
+                      <a:r>
+                        <a:rPr sz="1100" b="0">
+                          <a:solidFill>
+                            <a:srgbClr val="15181A"/>
+                          </a:solidFill>
+                          <a:latin typeface="Arial"/>
+                        </a:rPr>
+                        <a:t>HBR 2011; Thomasnet</a:t>
+                      </a:r>
+                    </a:p>
+                  </a:txBody>
+                  <a:tcPr marL="73152" marR="73152" marT="36576" marB="36576">
+                    <a:solidFill>
+                      <a:srgbClr val="FFFFFF"/>
+                    </a:solidFill>
+                  </a:tcPr>
+                </a:tc>
+              </a:tr>
+              <a:tr h="548640">
+                <a:tc>
+                  <a:txBody>
+                    <a:bodyPr/>
+                    <a:lstStyle/>
+                    <a:p>
+                      <a:r>
+                        <a:rPr sz="1100" b="0">
+                          <a:solidFill>
+                            <a:srgbClr val="15181A"/>
+                          </a:solidFill>
+                          <a:latin typeface="Arial"/>
+                        </a:rPr>
+                        <a:t>Dealer quote request</a:t>
+                      </a:r>
+                    </a:p>
+                  </a:txBody>
+                  <a:tcPr marL="73152" marR="73152" marT="36576" marB="36576">
+                    <a:solidFill>
+                      <a:srgbClr val="F2F5F2"/>
+                    </a:solidFill>
+                  </a:tcPr>
+                </a:tc>
+                <a:tc>
+                  <a:txBody>
+                    <a:bodyPr/>
+                    <a:lstStyle/>
+                    <a:p>
+                      <a:r>
+                        <a:rPr sz="1100" b="0">
+                          <a:solidFill>
+                            <a:srgbClr val="15181A"/>
+                          </a:solidFill>
+                          <a:latin typeface="Arial"/>
+                        </a:rPr>
+                        <a:t>Price and lead time fast enough to hold their customer</a:t>
+                      </a:r>
+                    </a:p>
+                  </a:txBody>
+                  <a:tcPr marL="73152" marR="73152" marT="36576" marB="36576">
+                    <a:solidFill>
+                      <a:srgbClr val="F2F5F2"/>
+                    </a:solidFill>
+                  </a:tcPr>
+                </a:tc>
+                <a:tc>
+                  <a:txBody>
+                    <a:bodyPr/>
+                    <a:lstStyle/>
+                    <a:p>
+                      <a:r>
+                        <a:rPr sz="1100" b="0">
+                          <a:solidFill>
+                            <a:srgbClr val="15181A"/>
+                          </a:solidFill>
+                          <a:latin typeface="Arial"/>
+                        </a:rPr>
+                        <a:t>Lead time is the #1 shortlist factor. 71% of manufacturers take a day or more to quote.</a:t>
+                      </a:r>
+                    </a:p>
+                  </a:txBody>
+                  <a:tcPr marL="73152" marR="73152" marT="36576" marB="36576">
+                    <a:solidFill>
+                      <a:srgbClr val="F2F5F2"/>
+                    </a:solidFill>
+                  </a:tcPr>
+                </a:tc>
+                <a:tc>
+                  <a:txBody>
+                    <a:bodyPr/>
+                    <a:lstStyle/>
+                    <a:p>
+                      <a:r>
+                        <a:rPr sz="1100" b="0">
+                          <a:solidFill>
+                            <a:srgbClr val="15181A"/>
+                          </a:solidFill>
+                          <a:latin typeface="Arial"/>
+                        </a:rPr>
+                        <a:t>Thomasnet 2021; Aleran 2025</a:t>
+                      </a:r>
+                    </a:p>
+                  </a:txBody>
+                  <a:tcPr marL="73152" marR="73152" marT="36576" marB="36576">
+                    <a:solidFill>
+                      <a:srgbClr val="F2F5F2"/>
+                    </a:solidFill>
+                  </a:tcPr>
+                </a:tc>
+              </a:tr>
+              <a:tr h="548640">
+                <a:tc>
+                  <a:txBody>
+                    <a:bodyPr/>
+                    <a:lstStyle/>
+                    <a:p>
+                      <a:r>
+                        <a:rPr sz="1100" b="0">
+                          <a:solidFill>
+                            <a:srgbClr val="15181A"/>
+                          </a:solidFill>
+                          <a:latin typeface="Arial"/>
+                        </a:rPr>
+                        <a:t>Application and drawings</a:t>
+                      </a:r>
+                    </a:p>
+                  </a:txBody>
+                  <a:tcPr marL="73152" marR="73152" marT="36576" marB="36576">
+                    <a:solidFill>
+                      <a:srgbClr val="FFFFFF"/>
+                    </a:solidFill>
+                  </a:tcPr>
+                </a:tc>
+                <a:tc>
+                  <a:txBody>
+                    <a:bodyPr/>
+                    <a:lstStyle/>
+                    <a:p>
+                      <a:r>
+                        <a:rPr sz="1100" b="0">
+                          <a:solidFill>
+                            <a:srgbClr val="15181A"/>
+                          </a:solidFill>
+                          <a:latin typeface="Arial"/>
+                        </a:rPr>
+                        <a:t>A rep and an engineer who know the job</a:t>
+                      </a:r>
+                    </a:p>
+                  </a:txBody>
+                  <a:tcPr marL="73152" marR="73152" marT="36576" marB="36576">
+                    <a:solidFill>
+                      <a:srgbClr val="FFFFFF"/>
+                    </a:solidFill>
+                  </a:tcPr>
+                </a:tc>
+                <a:tc>
+                  <a:txBody>
+                    <a:bodyPr/>
+                    <a:lstStyle/>
+                    <a:p>
+                      <a:r>
+                        <a:rPr sz="1100" b="0">
+                          <a:solidFill>
+                            <a:srgbClr val="15181A"/>
+                          </a:solidFill>
+                          <a:latin typeface="Arial"/>
+                        </a:rPr>
+                        <a:t>66% rate vendor engineers highly trustworthy. Rep-assisted buys carry half the regret.</a:t>
+                      </a:r>
+                    </a:p>
+                  </a:txBody>
+                  <a:tcPr marL="73152" marR="73152" marT="36576" marB="36576">
+                    <a:solidFill>
+                      <a:srgbClr val="FFFFFF"/>
+                    </a:solidFill>
+                  </a:tcPr>
+                </a:tc>
+                <a:tc>
+                  <a:txBody>
+                    <a:bodyPr/>
+                    <a:lstStyle/>
+                    <a:p>
+                      <a:r>
+                        <a:rPr sz="1100" b="0">
+                          <a:solidFill>
+                            <a:srgbClr val="15181A"/>
+                          </a:solidFill>
+                          <a:latin typeface="Arial"/>
+                        </a:rPr>
+                        <a:t>GlobalSpec 2026; Gartner</a:t>
+                      </a:r>
+                    </a:p>
+                  </a:txBody>
+                  <a:tcPr marL="73152" marR="73152" marT="36576" marB="36576">
+                    <a:solidFill>
+                      <a:srgbClr val="FFFFFF"/>
+                    </a:solidFill>
+                  </a:tcPr>
+                </a:tc>
+              </a:tr>
+              <a:tr h="548640">
+                <a:tc>
+                  <a:txBody>
+                    <a:bodyPr/>
+                    <a:lstStyle/>
+                    <a:p>
+                      <a:r>
+                        <a:rPr sz="1100" b="0">
+                          <a:solidFill>
+                            <a:srgbClr val="15181A"/>
+                          </a:solidFill>
+                          <a:latin typeface="Arial"/>
+                        </a:rPr>
+                        <a:t>Follow-up on an open quote</a:t>
+                      </a:r>
+                    </a:p>
+                  </a:txBody>
+                  <a:tcPr marL="73152" marR="73152" marT="36576" marB="36576">
+                    <a:solidFill>
+                      <a:srgbClr val="F2F5F2"/>
+                    </a:solidFill>
+                  </a:tcPr>
+                </a:tc>
+                <a:tc>
+                  <a:txBody>
+                    <a:bodyPr/>
+                    <a:lstStyle/>
+                    <a:p>
+                      <a:r>
+                        <a:rPr sz="1100" b="0">
+                          <a:solidFill>
+                            <a:srgbClr val="15181A"/>
+                          </a:solidFill>
+                          <a:latin typeface="Arial"/>
+                        </a:rPr>
+                        <a:t>We chase. They never have to.</a:t>
+                      </a:r>
+                    </a:p>
+                  </a:txBody>
+                  <a:tcPr marL="73152" marR="73152" marT="36576" marB="36576">
+                    <a:solidFill>
+                      <a:srgbClr val="F2F5F2"/>
+                    </a:solidFill>
+                  </a:tcPr>
+                </a:tc>
+                <a:tc>
+                  <a:txBody>
+                    <a:bodyPr/>
+                    <a:lstStyle/>
+                    <a:p>
+                      <a:r>
+                        <a:rPr sz="1100" b="0">
+                          <a:solidFill>
+                            <a:srgbClr val="15181A"/>
+                          </a:solidFill>
+                          <a:latin typeface="Arial"/>
+                        </a:rPr>
+                        <a:t>93% of conversions by the 6th call. "Follow up twice and I eliminate you."</a:t>
+                      </a:r>
+                    </a:p>
+                  </a:txBody>
+                  <a:tcPr marL="73152" marR="73152" marT="36576" marB="36576">
+                    <a:solidFill>
+                      <a:srgbClr val="F2F5F2"/>
+                    </a:solidFill>
+                  </a:tcPr>
+                </a:tc>
+                <a:tc>
+                  <a:txBody>
+                    <a:bodyPr/>
+                    <a:lstStyle/>
+                    <a:p>
+                      <a:r>
+                        <a:rPr sz="1100" b="0">
+                          <a:solidFill>
+                            <a:srgbClr val="15181A"/>
+                          </a:solidFill>
+                          <a:latin typeface="Arial"/>
+                        </a:rPr>
+                        <a:t>Velocify 2012; Thomasnet 2021</a:t>
+                      </a:r>
+                    </a:p>
+                  </a:txBody>
+                  <a:tcPr marL="73152" marR="73152" marT="36576" marB="36576">
+                    <a:solidFill>
+                      <a:srgbClr val="F2F5F2"/>
+                    </a:solidFill>
+                  </a:tcPr>
+                </a:tc>
+              </a:tr>
+              <a:tr h="548640">
+                <a:tc>
+                  <a:txBody>
+                    <a:bodyPr/>
+                    <a:lstStyle/>
+                    <a:p>
+                      <a:r>
+                        <a:rPr sz="1100" b="0">
+                          <a:solidFill>
+                            <a:srgbClr val="15181A"/>
+                          </a:solidFill>
+                          <a:latin typeface="Arial"/>
+                        </a:rPr>
+                        <a:t>Install, parts, and service</a:t>
+                      </a:r>
+                    </a:p>
+                  </a:txBody>
+                  <a:tcPr marL="73152" marR="73152" marT="36576" marB="36576">
+                    <a:solidFill>
+                      <a:srgbClr val="FFFFFF"/>
+                    </a:solidFill>
+                  </a:tcPr>
+                </a:tc>
+                <a:tc>
+                  <a:txBody>
+                    <a:bodyPr/>
+                    <a:lstStyle/>
+                    <a:p>
+                      <a:r>
+                        <a:rPr sz="1100" b="0">
+                          <a:solidFill>
+                            <a:srgbClr val="15181A"/>
+                          </a:solidFill>
+                          <a:latin typeface="Arial"/>
+                        </a:rPr>
+                        <a:t>Same-day response with a named owner</a:t>
+                      </a:r>
+                    </a:p>
+                  </a:txBody>
+                  <a:tcPr marL="73152" marR="73152" marT="36576" marB="36576">
+                    <a:solidFill>
+                      <a:srgbClr val="FFFFFF"/>
+                    </a:solidFill>
+                  </a:tcPr>
+                </a:tc>
+                <a:tc>
+                  <a:txBody>
+                    <a:bodyPr/>
+                    <a:lstStyle/>
+                    <a:p>
+                      <a:r>
+                        <a:rPr sz="1100" b="0">
+                          <a:solidFill>
+                            <a:srgbClr val="15181A"/>
+                          </a:solidFill>
+                          <a:latin typeface="Arial"/>
+                        </a:rPr>
+                        <a:t>95% rate fast service response very important. Poor service is the #2 reason buyers leave.</a:t>
+                      </a:r>
+                    </a:p>
+                  </a:txBody>
+                  <a:tcPr marL="73152" marR="73152" marT="36576" marB="36576">
+                    <a:solidFill>
+                      <a:srgbClr val="FFFFFF"/>
+                    </a:solidFill>
+                  </a:tcPr>
+                </a:tc>
+                <a:tc>
+                  <a:txBody>
+                    <a:bodyPr/>
+                    <a:lstStyle/>
+                    <a:p>
+                      <a:r>
+                        <a:rPr sz="1100" b="0">
+                          <a:solidFill>
+                            <a:srgbClr val="15181A"/>
+                          </a:solidFill>
+                          <a:latin typeface="Arial"/>
+                        </a:rPr>
+                        <a:t>MMH 2026; Salesforce 2024</a:t>
+                      </a:r>
+                    </a:p>
+                  </a:txBody>
+                  <a:tcPr marL="73152" marR="73152" marT="36576" marB="36576">
+                    <a:solidFill>
+                      <a:srgbClr val="FFFFFF"/>
+                    </a:solidFill>
+                  </a:tcPr>
+                </a:tc>
+              </a:tr>
+              <a:tr h="548640">
+                <a:tc>
+                  <a:txBody>
+                    <a:bodyPr/>
+                    <a:lstStyle/>
+                    <a:p>
+                      <a:r>
+                        <a:rPr sz="1100" b="0">
+                          <a:solidFill>
+                            <a:srgbClr val="15181A"/>
+                          </a:solidFill>
+                          <a:latin typeface="Arial"/>
+                        </a:rPr>
+                        <a:t>Existing accounts</a:t>
+                      </a:r>
+                    </a:p>
+                  </a:txBody>
+                  <a:tcPr marL="73152" marR="73152" marT="36576" marB="36576">
+                    <a:solidFill>
+                      <a:srgbClr val="F2F5F2"/>
+                    </a:solidFill>
+                  </a:tcPr>
+                </a:tc>
+                <a:tc>
+                  <a:txBody>
+                    <a:bodyPr/>
+                    <a:lstStyle/>
+                    <a:p>
+                      <a:r>
+                        <a:rPr sz="1100" b="0">
+                          <a:solidFill>
+                            <a:srgbClr val="15181A"/>
+                          </a:solidFill>
+                          <a:latin typeface="Arial"/>
+                        </a:rPr>
+                        <a:t>Contact between POs, not just at PO time</a:t>
+                      </a:r>
+                    </a:p>
+                  </a:txBody>
+                  <a:tcPr marL="73152" marR="73152" marT="36576" marB="36576">
+                    <a:solidFill>
+                      <a:srgbClr val="F2F5F2"/>
+                    </a:solidFill>
+                  </a:tcPr>
+                </a:tc>
+                <a:tc>
+                  <a:txBody>
+                    <a:bodyPr/>
+                    <a:lstStyle/>
+                    <a:p>
+                      <a:r>
+                        <a:rPr sz="1100" b="0">
+                          <a:solidFill>
+                            <a:srgbClr val="15181A"/>
+                          </a:solidFill>
+                          <a:latin typeface="Arial"/>
+                        </a:rPr>
+                        <a:t>73% of CSOs prioritize existing-customer growth. Aftermarket margins 2x equipment.</a:t>
+                      </a:r>
+                    </a:p>
+                  </a:txBody>
+                  <a:tcPr marL="73152" marR="73152" marT="36576" marB="36576">
+                    <a:solidFill>
+                      <a:srgbClr val="F2F5F2"/>
+                    </a:solidFill>
+                  </a:tcPr>
+                </a:tc>
+                <a:tc>
+                  <a:txBody>
+                    <a:bodyPr/>
+                    <a:lstStyle/>
+                    <a:p>
+                      <a:r>
+                        <a:rPr sz="1100" b="0">
+                          <a:solidFill>
+                            <a:srgbClr val="15181A"/>
+                          </a:solidFill>
+                          <a:latin typeface="Arial"/>
+                        </a:rPr>
+                        <a:t>Gartner 2025; Deloitte 2026</a:t>
+                      </a:r>
+                    </a:p>
+                  </a:txBody>
+                  <a:tcPr marL="73152" marR="73152" marT="36576" marB="36576">
+                    <a:solidFill>
+                      <a:srgbClr val="F2F5F2"/>
+                    </a:solidFill>
+                  </a:tcPr>
+                </a:tc>
+              </a:tr>
+            </a:tbl>
+          </a:graphicData>
+        </a:graphic>
+      </p:graphicFrame>
     </p:spTree>
   </p:cSld>
   <p:clrMapOvr>
@@ -13043,7 +15347,7 @@
           <a:lstStyle/>
           <a:p>
             <a:r>
-              <a:t>ROLLOUT</a:t>
+              <a:t>STANDARDS</a:t>
             </a:r>
           </a:p>
         </p:txBody>
@@ -13064,7 +15368,7 @@
           <a:lstStyle/>
           <a:p>
             <a:r>
-              <a:t>Measure first, then set the bar</a:t>
+              <a:t>Three standards we hold ourselves to</a:t>
             </a:r>
           </a:p>
         </p:txBody>
@@ -13085,7 +15389,7 @@
           <a:lstStyle/>
           <a:p>
             <a:r>
-              <a:t>We cannot manage response time until we can see it. Baseline comes before targets.</a:t>
+              <a:t>Each one maps to a number in this deck. Each one gets measured.</a:t>
             </a:r>
           </a:p>
         </p:txBody>
@@ -13106,7 +15410,7 @@
           <a:lstStyle/>
           <a:p>
             <a:r>
-              <a:t>OCT 2026</a:t>
+              <a:t>1. First touch inside one hour</a:t>
             </a:r>
           </a:p>
         </p:txBody>
@@ -13127,7 +15431,7 @@
           <a:lstStyle/>
           <a:p>
             <a:r>
-              <a:t>Baseline</a:t>
+              <a:t>Every inbound lead, web form, dealer inquiry, and RFQ gets a human acknowledgment within one business hour. A real answer or quote inside 24 hours. Nobody waits two days to hear from Steel King.</a:t>
             </a:r>
           </a:p>
         </p:txBody>
@@ -13139,16 +15443,16 @@
             <a:spLocks noGrp="1"/>
           </p:cNvSpPr>
           <p:nvPr>
-            <p:ph type="body" idx="108"/>
-          </p:nvPr>
-        </p:nvSpPr>
-        <p:spPr/>
-        <p:txBody>
-          <a:bodyPr/>
-          <a:lstStyle/>
-          <a:p>
-            <a:r>
-              <a:t>Pull current response times for web leads, dealer RFQs, and service requests. Secret-shop our own inbound. Owner: Nate with inside sales.</a:t>
+            <p:ph type="body" idx="111"/>
+          </p:nvPr>
+        </p:nvSpPr>
+        <p:spPr/>
+        <p:txBody>
+          <a:bodyPr/>
+          <a:lstStyle/>
+          <a:p>
+            <a:r>
+              <a:t>2. Six touches before we close a lead</a:t>
             </a:r>
           </a:p>
         </p:txBody>
@@ -13160,16 +15464,16 @@
             <a:spLocks noGrp="1"/>
           </p:cNvSpPr>
           <p:nvPr>
-            <p:ph type="body" idx="111"/>
-          </p:nvPr>
-        </p:nvSpPr>
-        <p:spPr/>
-        <p:txBody>
-          <a:bodyPr/>
-          <a:lstStyle/>
-          <a:p>
-            <a:r>
-              <a:t>NOV 2026</a:t>
+            <p:ph type="body" idx="112"/>
+          </p:nvPr>
+        </p:nvSpPr>
+        <p:spPr/>
+        <p:txBody>
+          <a:bodyPr/>
+          <a:lstStyle/>
+          <a:p>
+            <a:r>
+              <a:t>No lead is marked dead after one call. Minimum six touches across phone and email over two weeks, each with something useful: a drawing, a lead time, a reference. Log every touch.</a:t>
             </a:r>
           </a:p>
         </p:txBody>
@@ -13181,16 +15485,16 @@
             <a:spLocks noGrp="1"/>
           </p:cNvSpPr>
           <p:nvPr>
-            <p:ph type="body" idx="112"/>
-          </p:nvPr>
-        </p:nvSpPr>
-        <p:spPr/>
-        <p:txBody>
-          <a:bodyPr/>
-          <a:lstStyle/>
-          <a:p>
-            <a:r>
-              <a:t>Standards and cadence</a:t>
+            <p:ph type="body" idx="116"/>
+          </p:nvPr>
+        </p:nvSpPr>
+        <p:spPr/>
+        <p:txBody>
+          <a:bodyPr/>
+          <a:lstStyle/>
+          <a:p>
+            <a:r>
+              <a:t>3. Same-day service response</a:t>
             </a:r>
           </a:p>
         </p:txBody>
@@ -13202,16 +15506,16 @@
             <a:spLocks noGrp="1"/>
           </p:cNvSpPr>
           <p:nvPr>
-            <p:ph type="body" idx="113"/>
-          </p:nvPr>
-        </p:nvSpPr>
-        <p:spPr/>
-        <p:txBody>
-          <a:bodyPr/>
-          <a:lstStyle/>
-          <a:p>
-            <a:r>
-              <a:t>Agree the three standards. Build the six-touch cadence and templates. Assign lead ownership rules. Owner: regional managers.</a:t>
+            <p:ph type="body" idx="117"/>
+          </p:nvPr>
+        </p:nvSpPr>
+        <p:spPr/>
+        <p:txBody>
+          <a:bodyPr/>
+          <a:lstStyle/>
+          <a:p>
+            <a:r>
+              <a:t>Post-sale questions, parts, and install issues get a same-day reply and a named owner. Dealer questions answered within four business hours. Response time reported monthly next to bookings.</a:t>
             </a:r>
           </a:p>
         </p:txBody>
@@ -13223,48 +15527,6 @@
             <a:spLocks noGrp="1"/>
           </p:cNvSpPr>
           <p:nvPr>
-            <p:ph type="body" idx="116"/>
-          </p:nvPr>
-        </p:nvSpPr>
-        <p:spPr/>
-        <p:txBody>
-          <a:bodyPr/>
-          <a:lstStyle/>
-          <a:p>
-            <a:r>
-              <a:t>DEC 2026</a:t>
-            </a:r>
-          </a:p>
-        </p:txBody>
-      </p:sp>
-      <p:sp>
-        <p:nvSpPr>
-          <p:cNvPr id="12" name="Text Placeholder 11"/>
-          <p:cNvSpPr>
-            <a:spLocks noGrp="1"/>
-          </p:cNvSpPr>
-          <p:nvPr>
-            <p:ph type="body" idx="117"/>
-          </p:nvPr>
-        </p:nvSpPr>
-        <p:spPr/>
-        <p:txBody>
-          <a:bodyPr/>
-          <a:lstStyle/>
-          <a:p>
-            <a:r>
-              <a:t>Tools and dashboard</a:t>
-            </a:r>
-          </a:p>
-        </p:txBody>
-      </p:sp>
-      <p:sp>
-        <p:nvSpPr>
-          <p:cNvPr id="13" name="Text Placeholder 12"/>
-          <p:cNvSpPr>
-            <a:spLocks noGrp="1"/>
-          </p:cNvSpPr>
-          <p:nvPr>
             <p:ph type="body" idx="118"/>
           </p:nvPr>
         </p:nvSpPr>
@@ -13274,91 +15536,7 @@
           <a:lstStyle/>
           <a:p>
             <a:r>
-              <a:t>Route leads with alerts. Response-time report by rep and by dealer. Owner: marketing and inside sales.</a:t>
-            </a:r>
-          </a:p>
-        </p:txBody>
-      </p:sp>
-      <p:sp>
-        <p:nvSpPr>
-          <p:cNvPr id="14" name="Text Placeholder 13"/>
-          <p:cNvSpPr>
-            <a:spLocks noGrp="1"/>
-          </p:cNvSpPr>
-          <p:nvPr>
-            <p:ph type="body" idx="121"/>
-          </p:nvPr>
-        </p:nvSpPr>
-        <p:spPr/>
-        <p:txBody>
-          <a:bodyPr/>
-          <a:lstStyle/>
-          <a:p>
-            <a:r>
-              <a:t>Q1 2027</a:t>
-            </a:r>
-          </a:p>
-        </p:txBody>
-      </p:sp>
-      <p:sp>
-        <p:nvSpPr>
-          <p:cNvPr id="15" name="Text Placeholder 14"/>
-          <p:cNvSpPr>
-            <a:spLocks noGrp="1"/>
-          </p:cNvSpPr>
-          <p:nvPr>
-            <p:ph type="body" idx="122"/>
-          </p:nvPr>
-        </p:nvSpPr>
-        <p:spPr/>
-        <p:txBody>
-          <a:bodyPr/>
-          <a:lstStyle/>
-          <a:p>
-            <a:r>
-              <a:t>Scorecard and review</a:t>
-            </a:r>
-          </a:p>
-        </p:txBody>
-      </p:sp>
-      <p:sp>
-        <p:nvSpPr>
-          <p:cNvPr id="16" name="Text Placeholder 15"/>
-          <p:cNvSpPr>
-            <a:spLocks noGrp="1"/>
-          </p:cNvSpPr>
-          <p:nvPr>
-            <p:ph type="body" idx="123"/>
-          </p:nvPr>
-        </p:nvSpPr>
-        <p:spPr/>
-        <p:txBody>
-          <a:bodyPr/>
-          <a:lstStyle/>
-          <a:p>
-            <a:r>
-              <a:t>Response time and follow-up rate on the sales scorecard. Review monthly in L10. Owner: Nate.</a:t>
-            </a:r>
-          </a:p>
-        </p:txBody>
-      </p:sp>
-      <p:sp>
-        <p:nvSpPr>
-          <p:cNvPr id="17" name="Text Placeholder 16"/>
-          <p:cNvSpPr>
-            <a:spLocks noGrp="1"/>
-          </p:cNvSpPr>
-          <p:nvPr>
-            <p:ph type="body" idx="124"/>
-          </p:nvPr>
-        </p:nvSpPr>
-        <p:spPr/>
-        <p:txBody>
-          <a:bodyPr/>
-          <a:lstStyle/>
-          <a:p>
-            <a:r>
-              <a:t>Source: Dates are proposed and can move with the team's input.</a:t>
+              <a:t>Source: Proposed. Targets set from the research above; final numbers to be confirmed with the team.</a:t>
             </a:r>
           </a:p>
         </p:txBody>
@@ -13388,16 +15566,16 @@
             <a:spLocks noGrp="1"/>
           </p:cNvSpPr>
           <p:nvPr>
-            <p:ph type="body" idx="101"/>
-          </p:nvPr>
-        </p:nvSpPr>
-        <p:spPr/>
-        <p:txBody>
-          <a:bodyPr/>
-          <a:lstStyle/>
-          <a:p>
-            <a:r>
-              <a:t>THE POINT</a:t>
+            <p:ph type="body" idx="100"/>
+          </p:nvPr>
+        </p:nvSpPr>
+        <p:spPr/>
+        <p:txBody>
+          <a:bodyPr/>
+          <a:lstStyle/>
+          <a:p>
+            <a:r>
+              <a:t>ROLLOUT</a:t>
             </a:r>
           </a:p>
         </p:txBody>
@@ -13409,16 +15587,16 @@
             <a:spLocks noGrp="1"/>
           </p:cNvSpPr>
           <p:nvPr>
-            <p:ph type="title" idx="103"/>
-          </p:nvPr>
-        </p:nvSpPr>
-        <p:spPr/>
-        <p:txBody>
-          <a:bodyPr/>
-          <a:lstStyle/>
-          <a:p>
-            <a:r>
-              <a:t>Nobody buys rack because we called back fast. They stop considering us because we didn't.</a:t>
+            <p:ph type="title" idx="101"/>
+          </p:nvPr>
+        </p:nvSpPr>
+        <p:spPr/>
+        <p:txBody>
+          <a:bodyPr/>
+          <a:lstStyle/>
+          <a:p>
+            <a:r>
+              <a:t>Measure first, then set the bar</a:t>
             </a:r>
           </a:p>
         </p:txBody>
@@ -13430,16 +15608,289 @@
             <a:spLocks noGrp="1"/>
           </p:cNvSpPr>
           <p:nvPr>
-            <p:ph type="body" idx="104"/>
-          </p:nvPr>
-        </p:nvSpPr>
-        <p:spPr/>
-        <p:txBody>
-          <a:bodyPr/>
-          <a:lstStyle/>
-          <a:p>
-            <a:r>
-              <a:t>Speed and service don't win on their own. They keep us on the shortlist long enough for product and price to win.</a:t>
+            <p:ph type="body" idx="102"/>
+          </p:nvPr>
+        </p:nvSpPr>
+        <p:spPr/>
+        <p:txBody>
+          <a:bodyPr/>
+          <a:lstStyle/>
+          <a:p>
+            <a:r>
+              <a:t>We cannot manage response time until we can see it. Baseline comes before targets.</a:t>
+            </a:r>
+          </a:p>
+        </p:txBody>
+      </p:sp>
+      <p:sp>
+        <p:nvSpPr>
+          <p:cNvPr id="5" name="Text Placeholder 4"/>
+          <p:cNvSpPr>
+            <a:spLocks noGrp="1"/>
+          </p:cNvSpPr>
+          <p:nvPr>
+            <p:ph type="body" idx="106"/>
+          </p:nvPr>
+        </p:nvSpPr>
+        <p:spPr/>
+        <p:txBody>
+          <a:bodyPr/>
+          <a:lstStyle/>
+          <a:p>
+            <a:r>
+              <a:t>OCT 2026</a:t>
+            </a:r>
+          </a:p>
+        </p:txBody>
+      </p:sp>
+      <p:sp>
+        <p:nvSpPr>
+          <p:cNvPr id="6" name="Text Placeholder 5"/>
+          <p:cNvSpPr>
+            <a:spLocks noGrp="1"/>
+          </p:cNvSpPr>
+          <p:nvPr>
+            <p:ph type="body" idx="107"/>
+          </p:nvPr>
+        </p:nvSpPr>
+        <p:spPr/>
+        <p:txBody>
+          <a:bodyPr/>
+          <a:lstStyle/>
+          <a:p>
+            <a:r>
+              <a:t>Baseline</a:t>
+            </a:r>
+          </a:p>
+        </p:txBody>
+      </p:sp>
+      <p:sp>
+        <p:nvSpPr>
+          <p:cNvPr id="7" name="Text Placeholder 6"/>
+          <p:cNvSpPr>
+            <a:spLocks noGrp="1"/>
+          </p:cNvSpPr>
+          <p:nvPr>
+            <p:ph type="body" idx="108"/>
+          </p:nvPr>
+        </p:nvSpPr>
+        <p:spPr/>
+        <p:txBody>
+          <a:bodyPr/>
+          <a:lstStyle/>
+          <a:p>
+            <a:r>
+              <a:t>Pull current response times for web leads, dealer RFQs, and service requests. Secret-shop our own inbound. Owner: Nate with inside sales.</a:t>
+            </a:r>
+          </a:p>
+        </p:txBody>
+      </p:sp>
+      <p:sp>
+        <p:nvSpPr>
+          <p:cNvPr id="8" name="Text Placeholder 7"/>
+          <p:cNvSpPr>
+            <a:spLocks noGrp="1"/>
+          </p:cNvSpPr>
+          <p:nvPr>
+            <p:ph type="body" idx="111"/>
+          </p:nvPr>
+        </p:nvSpPr>
+        <p:spPr/>
+        <p:txBody>
+          <a:bodyPr/>
+          <a:lstStyle/>
+          <a:p>
+            <a:r>
+              <a:t>NOV 2026</a:t>
+            </a:r>
+          </a:p>
+        </p:txBody>
+      </p:sp>
+      <p:sp>
+        <p:nvSpPr>
+          <p:cNvPr id="9" name="Text Placeholder 8"/>
+          <p:cNvSpPr>
+            <a:spLocks noGrp="1"/>
+          </p:cNvSpPr>
+          <p:nvPr>
+            <p:ph type="body" idx="112"/>
+          </p:nvPr>
+        </p:nvSpPr>
+        <p:spPr/>
+        <p:txBody>
+          <a:bodyPr/>
+          <a:lstStyle/>
+          <a:p>
+            <a:r>
+              <a:t>Standards and cadence</a:t>
+            </a:r>
+          </a:p>
+        </p:txBody>
+      </p:sp>
+      <p:sp>
+        <p:nvSpPr>
+          <p:cNvPr id="10" name="Text Placeholder 9"/>
+          <p:cNvSpPr>
+            <a:spLocks noGrp="1"/>
+          </p:cNvSpPr>
+          <p:nvPr>
+            <p:ph type="body" idx="113"/>
+          </p:nvPr>
+        </p:nvSpPr>
+        <p:spPr/>
+        <p:txBody>
+          <a:bodyPr/>
+          <a:lstStyle/>
+          <a:p>
+            <a:r>
+              <a:t>Agree the three standards. Build the six-touch cadence and templates. Assign lead ownership rules. Owner: regional managers.</a:t>
+            </a:r>
+          </a:p>
+        </p:txBody>
+      </p:sp>
+      <p:sp>
+        <p:nvSpPr>
+          <p:cNvPr id="11" name="Text Placeholder 10"/>
+          <p:cNvSpPr>
+            <a:spLocks noGrp="1"/>
+          </p:cNvSpPr>
+          <p:nvPr>
+            <p:ph type="body" idx="116"/>
+          </p:nvPr>
+        </p:nvSpPr>
+        <p:spPr/>
+        <p:txBody>
+          <a:bodyPr/>
+          <a:lstStyle/>
+          <a:p>
+            <a:r>
+              <a:t>DEC 2026</a:t>
+            </a:r>
+          </a:p>
+        </p:txBody>
+      </p:sp>
+      <p:sp>
+        <p:nvSpPr>
+          <p:cNvPr id="12" name="Text Placeholder 11"/>
+          <p:cNvSpPr>
+            <a:spLocks noGrp="1"/>
+          </p:cNvSpPr>
+          <p:nvPr>
+            <p:ph type="body" idx="117"/>
+          </p:nvPr>
+        </p:nvSpPr>
+        <p:spPr/>
+        <p:txBody>
+          <a:bodyPr/>
+          <a:lstStyle/>
+          <a:p>
+            <a:r>
+              <a:t>Tools and dashboard</a:t>
+            </a:r>
+          </a:p>
+        </p:txBody>
+      </p:sp>
+      <p:sp>
+        <p:nvSpPr>
+          <p:cNvPr id="13" name="Text Placeholder 12"/>
+          <p:cNvSpPr>
+            <a:spLocks noGrp="1"/>
+          </p:cNvSpPr>
+          <p:nvPr>
+            <p:ph type="body" idx="118"/>
+          </p:nvPr>
+        </p:nvSpPr>
+        <p:spPr/>
+        <p:txBody>
+          <a:bodyPr/>
+          <a:lstStyle/>
+          <a:p>
+            <a:r>
+              <a:t>Route leads with alerts. Response-time report by rep and by dealer. Owner: marketing and inside sales.</a:t>
+            </a:r>
+          </a:p>
+        </p:txBody>
+      </p:sp>
+      <p:sp>
+        <p:nvSpPr>
+          <p:cNvPr id="14" name="Text Placeholder 13"/>
+          <p:cNvSpPr>
+            <a:spLocks noGrp="1"/>
+          </p:cNvSpPr>
+          <p:nvPr>
+            <p:ph type="body" idx="121"/>
+          </p:nvPr>
+        </p:nvSpPr>
+        <p:spPr/>
+        <p:txBody>
+          <a:bodyPr/>
+          <a:lstStyle/>
+          <a:p>
+            <a:r>
+              <a:t>Q1 2027</a:t>
+            </a:r>
+          </a:p>
+        </p:txBody>
+      </p:sp>
+      <p:sp>
+        <p:nvSpPr>
+          <p:cNvPr id="15" name="Text Placeholder 14"/>
+          <p:cNvSpPr>
+            <a:spLocks noGrp="1"/>
+          </p:cNvSpPr>
+          <p:nvPr>
+            <p:ph type="body" idx="122"/>
+          </p:nvPr>
+        </p:nvSpPr>
+        <p:spPr/>
+        <p:txBody>
+          <a:bodyPr/>
+          <a:lstStyle/>
+          <a:p>
+            <a:r>
+              <a:t>Scorecard and review</a:t>
+            </a:r>
+          </a:p>
+        </p:txBody>
+      </p:sp>
+      <p:sp>
+        <p:nvSpPr>
+          <p:cNvPr id="16" name="Text Placeholder 15"/>
+          <p:cNvSpPr>
+            <a:spLocks noGrp="1"/>
+          </p:cNvSpPr>
+          <p:nvPr>
+            <p:ph type="body" idx="123"/>
+          </p:nvPr>
+        </p:nvSpPr>
+        <p:spPr/>
+        <p:txBody>
+          <a:bodyPr/>
+          <a:lstStyle/>
+          <a:p>
+            <a:r>
+              <a:t>Response time and follow-up rate on the sales scorecard. Review monthly in L10. Owner: Nate.</a:t>
+            </a:r>
+          </a:p>
+        </p:txBody>
+      </p:sp>
+      <p:sp>
+        <p:nvSpPr>
+          <p:cNvPr id="17" name="Text Placeholder 16"/>
+          <p:cNvSpPr>
+            <a:spLocks noGrp="1"/>
+          </p:cNvSpPr>
+          <p:nvPr>
+            <p:ph type="body" idx="124"/>
+          </p:nvPr>
+        </p:nvSpPr>
+        <p:spPr/>
+        <p:txBody>
+          <a:bodyPr/>
+          <a:lstStyle/>
+          <a:p>
+            <a:r>
+              <a:t>Source: Dates are proposed and can move with the team's input.</a:t>
             </a:r>
           </a:p>
         </p:txBody>
@@ -13453,6 +15904,87 @@
 </file>
 
 <file path=ppt/slides/slide23.xml><?xml version="1.0" encoding="utf-8"?>
+<p:sld xmlns:a="http://schemas.openxmlformats.org/drawingml/2006/main" xmlns:p="http://schemas.openxmlformats.org/presentationml/2006/main" xmlns:r="http://schemas.openxmlformats.org/officeDocument/2006/relationships">
+  <p:cSld>
+    <p:spTree>
+      <p:nvGrpSpPr>
+        <p:cNvPr id="1" name=""/>
+        <p:cNvGrpSpPr/>
+        <p:nvPr/>
+      </p:nvGrpSpPr>
+      <p:grpSpPr/>
+      <p:sp>
+        <p:nvSpPr>
+          <p:cNvPr id="2" name="Text Placeholder 1"/>
+          <p:cNvSpPr>
+            <a:spLocks noGrp="1"/>
+          </p:cNvSpPr>
+          <p:nvPr>
+            <p:ph type="body" idx="101"/>
+          </p:nvPr>
+        </p:nvSpPr>
+        <p:spPr/>
+        <p:txBody>
+          <a:bodyPr/>
+          <a:lstStyle/>
+          <a:p>
+            <a:r>
+              <a:t>THE POINT</a:t>
+            </a:r>
+          </a:p>
+        </p:txBody>
+      </p:sp>
+      <p:sp>
+        <p:nvSpPr>
+          <p:cNvPr id="3" name="Title 2"/>
+          <p:cNvSpPr>
+            <a:spLocks noGrp="1"/>
+          </p:cNvSpPr>
+          <p:nvPr>
+            <p:ph type="title" idx="103"/>
+          </p:nvPr>
+        </p:nvSpPr>
+        <p:spPr/>
+        <p:txBody>
+          <a:bodyPr/>
+          <a:lstStyle/>
+          <a:p>
+            <a:r>
+              <a:t>Nobody buys rack because we called back fast. They stop considering us because we didn't.</a:t>
+            </a:r>
+          </a:p>
+        </p:txBody>
+      </p:sp>
+      <p:sp>
+        <p:nvSpPr>
+          <p:cNvPr id="4" name="Text Placeholder 3"/>
+          <p:cNvSpPr>
+            <a:spLocks noGrp="1"/>
+          </p:cNvSpPr>
+          <p:nvPr>
+            <p:ph type="body" idx="104"/>
+          </p:nvPr>
+        </p:nvSpPr>
+        <p:spPr/>
+        <p:txBody>
+          <a:bodyPr/>
+          <a:lstStyle/>
+          <a:p>
+            <a:r>
+              <a:t>Speed and service don't win on their own. They keep us on the shortlist long enough for product and price to win.</a:t>
+            </a:r>
+          </a:p>
+        </p:txBody>
+      </p:sp>
+    </p:spTree>
+  </p:cSld>
+  <p:clrMapOvr>
+    <a:masterClrMapping/>
+  </p:clrMapOvr>
+</p:sld>
+</file>
+
+<file path=ppt/slides/slide24.xml><?xml version="1.0" encoding="utf-8"?>
 <p:sld xmlns:a="http://schemas.openxmlformats.org/drawingml/2006/main" xmlns:p="http://schemas.openxmlformats.org/presentationml/2006/main" xmlns:r="http://schemas.openxmlformats.org/officeDocument/2006/relationships">
   <p:cSld>
     <p:spTree>
@@ -13587,7 +16119,7 @@
                       </a:r>
                     </a:p>
                   </a:txBody>
-                  <a:tcPr marL="73152" marR="73152" marT="45720" marB="45720">
+                  <a:tcPr marL="73152" marR="73152" marT="36576" marB="36576">
                     <a:solidFill>
                       <a:srgbClr val="3C7D4D"/>
                     </a:solidFill>
@@ -13609,7 +16141,7 @@
                       </a:r>
                     </a:p>
                   </a:txBody>
-                  <a:tcPr marL="73152" marR="73152" marT="45720" marB="45720">
+                  <a:tcPr marL="73152" marR="73152" marT="36576" marB="36576">
                     <a:solidFill>
                       <a:srgbClr val="3C7D4D"/>
                     </a:solidFill>
@@ -13631,7 +16163,7 @@
                       </a:r>
                     </a:p>
                   </a:txBody>
-                  <a:tcPr marL="73152" marR="73152" marT="45720" marB="45720">
+                  <a:tcPr marL="73152" marR="73152" marT="36576" marB="36576">
                     <a:solidFill>
                       <a:srgbClr val="3C7D4D"/>
                     </a:solidFill>
@@ -13653,7 +16185,7 @@
                       </a:r>
                     </a:p>
                   </a:txBody>
-                  <a:tcPr marL="73152" marR="73152" marT="45720" marB="45720">
+                  <a:tcPr marL="73152" marR="73152" marT="36576" marB="36576">
                     <a:solidFill>
                       <a:srgbClr val="3C7D4D"/>
                     </a:solidFill>
@@ -13677,7 +16209,7 @@
                       </a:r>
                     </a:p>
                   </a:txBody>
-                  <a:tcPr marL="73152" marR="73152" marT="45720" marB="45720">
+                  <a:tcPr marL="73152" marR="73152" marT="36576" marB="36576">
                     <a:solidFill>
                       <a:srgbClr val="FFFFFF"/>
                     </a:solidFill>
@@ -13699,7 +16231,7 @@
                       </a:r>
                     </a:p>
                   </a:txBody>
-                  <a:tcPr marL="73152" marR="73152" marT="45720" marB="45720">
+                  <a:tcPr marL="73152" marR="73152" marT="36576" marB="36576">
                     <a:solidFill>
                       <a:srgbClr val="FFFFFF"/>
                     </a:solidFill>
@@ -13721,7 +16253,7 @@
                       </a:r>
                     </a:p>
                   </a:txBody>
-                  <a:tcPr marL="73152" marR="73152" marT="45720" marB="45720">
+                  <a:tcPr marL="73152" marR="73152" marT="36576" marB="36576">
                     <a:solidFill>
                       <a:srgbClr val="FFFFFF"/>
                     </a:solidFill>
@@ -13743,7 +16275,7 @@
                       </a:r>
                     </a:p>
                   </a:txBody>
-                  <a:tcPr marL="73152" marR="73152" marT="45720" marB="45720">
+                  <a:tcPr marL="73152" marR="73152" marT="36576" marB="36576">
                     <a:solidFill>
                       <a:srgbClr val="FFFFFF"/>
                     </a:solidFill>
@@ -13767,7 +16299,7 @@
                       </a:r>
                     </a:p>
                   </a:txBody>
-                  <a:tcPr marL="73152" marR="73152" marT="45720" marB="45720">
+                  <a:tcPr marL="73152" marR="73152" marT="36576" marB="36576">
                     <a:solidFill>
                       <a:srgbClr val="F2F5F2"/>
                     </a:solidFill>
@@ -13789,7 +16321,7 @@
                       </a:r>
                     </a:p>
                   </a:txBody>
-                  <a:tcPr marL="73152" marR="73152" marT="45720" marB="45720">
+                  <a:tcPr marL="73152" marR="73152" marT="36576" marB="36576">
                     <a:solidFill>
                       <a:srgbClr val="F2F5F2"/>
                     </a:solidFill>
@@ -13811,7 +16343,7 @@
                       </a:r>
                     </a:p>
                   </a:txBody>
-                  <a:tcPr marL="73152" marR="73152" marT="45720" marB="45720">
+                  <a:tcPr marL="73152" marR="73152" marT="36576" marB="36576">
                     <a:solidFill>
                       <a:srgbClr val="F2F5F2"/>
                     </a:solidFill>
@@ -13833,7 +16365,7 @@
                       </a:r>
                     </a:p>
                   </a:txBody>
-                  <a:tcPr marL="73152" marR="73152" marT="45720" marB="45720">
+                  <a:tcPr marL="73152" marR="73152" marT="36576" marB="36576">
                     <a:solidFill>
                       <a:srgbClr val="F2F5F2"/>
                     </a:solidFill>
@@ -13857,7 +16389,7 @@
                       </a:r>
                     </a:p>
                   </a:txBody>
-                  <a:tcPr marL="73152" marR="73152" marT="45720" marB="45720">
+                  <a:tcPr marL="73152" marR="73152" marT="36576" marB="36576">
                     <a:solidFill>
                       <a:srgbClr val="FFFFFF"/>
                     </a:solidFill>
@@ -13879,7 +16411,7 @@
                       </a:r>
                     </a:p>
                   </a:txBody>
-                  <a:tcPr marL="73152" marR="73152" marT="45720" marB="45720">
+                  <a:tcPr marL="73152" marR="73152" marT="36576" marB="36576">
                     <a:solidFill>
                       <a:srgbClr val="FFFFFF"/>
                     </a:solidFill>
@@ -13901,7 +16433,7 @@
                       </a:r>
                     </a:p>
                   </a:txBody>
-                  <a:tcPr marL="73152" marR="73152" marT="45720" marB="45720">
+                  <a:tcPr marL="73152" marR="73152" marT="36576" marB="36576">
                     <a:solidFill>
                       <a:srgbClr val="FFFFFF"/>
                     </a:solidFill>
@@ -13923,7 +16455,7 @@
                       </a:r>
                     </a:p>
                   </a:txBody>
-                  <a:tcPr marL="73152" marR="73152" marT="45720" marB="45720">
+                  <a:tcPr marL="73152" marR="73152" marT="36576" marB="36576">
                     <a:solidFill>
                       <a:srgbClr val="FFFFFF"/>
                     </a:solidFill>
@@ -13947,7 +16479,7 @@
                       </a:r>
                     </a:p>
                   </a:txBody>
-                  <a:tcPr marL="73152" marR="73152" marT="45720" marB="45720">
+                  <a:tcPr marL="73152" marR="73152" marT="36576" marB="36576">
                     <a:solidFill>
                       <a:srgbClr val="F2F5F2"/>
                     </a:solidFill>
@@ -13969,7 +16501,7 @@
                       </a:r>
                     </a:p>
                   </a:txBody>
-                  <a:tcPr marL="73152" marR="73152" marT="45720" marB="45720">
+                  <a:tcPr marL="73152" marR="73152" marT="36576" marB="36576">
                     <a:solidFill>
                       <a:srgbClr val="F2F5F2"/>
                     </a:solidFill>
@@ -13991,7 +16523,7 @@
                       </a:r>
                     </a:p>
                   </a:txBody>
-                  <a:tcPr marL="73152" marR="73152" marT="45720" marB="45720">
+                  <a:tcPr marL="73152" marR="73152" marT="36576" marB="36576">
                     <a:solidFill>
                       <a:srgbClr val="F2F5F2"/>
                     </a:solidFill>
@@ -14013,7 +16545,7 @@
                       </a:r>
                     </a:p>
                   </a:txBody>
-                  <a:tcPr marL="73152" marR="73152" marT="45720" marB="45720">
+                  <a:tcPr marL="73152" marR="73152" marT="36576" marB="36576">
                     <a:solidFill>
                       <a:srgbClr val="F2F5F2"/>
                     </a:solidFill>
@@ -14037,7 +16569,7 @@
                       </a:r>
                     </a:p>
                   </a:txBody>
-                  <a:tcPr marL="73152" marR="73152" marT="45720" marB="45720">
+                  <a:tcPr marL="73152" marR="73152" marT="36576" marB="36576">
                     <a:solidFill>
                       <a:srgbClr val="FFFFFF"/>
                     </a:solidFill>
@@ -14059,7 +16591,7 @@
                       </a:r>
                     </a:p>
                   </a:txBody>
-                  <a:tcPr marL="73152" marR="73152" marT="45720" marB="45720">
+                  <a:tcPr marL="73152" marR="73152" marT="36576" marB="36576">
                     <a:solidFill>
                       <a:srgbClr val="FFFFFF"/>
                     </a:solidFill>
@@ -14081,7 +16613,7 @@
                       </a:r>
                     </a:p>
                   </a:txBody>
-                  <a:tcPr marL="73152" marR="73152" marT="45720" marB="45720">
+                  <a:tcPr marL="73152" marR="73152" marT="36576" marB="36576">
                     <a:solidFill>
                       <a:srgbClr val="FFFFFF"/>
                     </a:solidFill>
@@ -14103,7 +16635,7 @@
                       </a:r>
                     </a:p>
                   </a:txBody>
-                  <a:tcPr marL="73152" marR="73152" marT="45720" marB="45720">
+                  <a:tcPr marL="73152" marR="73152" marT="36576" marB="36576">
                     <a:solidFill>
                       <a:srgbClr val="FFFFFF"/>
                     </a:solidFill>
@@ -14127,7 +16659,7 @@
                       </a:r>
                     </a:p>
                   </a:txBody>
-                  <a:tcPr marL="73152" marR="73152" marT="45720" marB="45720">
+                  <a:tcPr marL="73152" marR="73152" marT="36576" marB="36576">
                     <a:solidFill>
                       <a:srgbClr val="F2F5F2"/>
                     </a:solidFill>
@@ -14149,7 +16681,7 @@
                       </a:r>
                     </a:p>
                   </a:txBody>
-                  <a:tcPr marL="73152" marR="73152" marT="45720" marB="45720">
+                  <a:tcPr marL="73152" marR="73152" marT="36576" marB="36576">
                     <a:solidFill>
                       <a:srgbClr val="F2F5F2"/>
                     </a:solidFill>
@@ -14171,7 +16703,7 @@
                       </a:r>
                     </a:p>
                   </a:txBody>
-                  <a:tcPr marL="73152" marR="73152" marT="45720" marB="45720">
+                  <a:tcPr marL="73152" marR="73152" marT="36576" marB="36576">
                     <a:solidFill>
                       <a:srgbClr val="F2F5F2"/>
                     </a:solidFill>
@@ -14193,7 +16725,7 @@
                       </a:r>
                     </a:p>
                   </a:txBody>
-                  <a:tcPr marL="73152" marR="73152" marT="45720" marB="45720">
+                  <a:tcPr marL="73152" marR="73152" marT="36576" marB="36576">
                     <a:solidFill>
                       <a:srgbClr val="F2F5F2"/>
                     </a:solidFill>
@@ -14212,7 +16744,7 @@
 </p:sld>
 </file>
 
-<file path=ppt/slides/slide24.xml><?xml version="1.0" encoding="utf-8"?>
+<file path=ppt/slides/slide25.xml><?xml version="1.0" encoding="utf-8"?>
 <p:sld xmlns:a="http://schemas.openxmlformats.org/drawingml/2006/main" xmlns:p="http://schemas.openxmlformats.org/presentationml/2006/main" xmlns:r="http://schemas.openxmlformats.org/officeDocument/2006/relationships">
   <p:cSld>
     <p:spTree>
@@ -14796,7 +17328,7 @@
           <a:lstStyle/>
           <a:p>
             <a:r>
-              <a:t>Top equipment priority in the 2026 and 2025 MMH outlook surveys</a:t>
+              <a:t>Top equipment category in the 2026 and 2025 MMH outlook surveys</a:t>
             </a:r>
           </a:p>
         </p:txBody>
@@ -15189,7 +17721,7 @@
           <a:lstStyle/>
           <a:p>
             <a:r>
-              <a:t>Before a technical buyer contacts anyone at the vendor</a:t>
+              <a:t>Engineers and technical buyers, before contacting anyone at the vendor</a:t>
             </a:r>
           </a:p>
         </p:txBody>
@@ -15252,7 +17784,7 @@
           <a:lstStyle/>
           <a:p>
             <a:r>
-              <a:t>Industrial buyers; only 3% look at more than ten</a:t>
+              <a:t>Industrial buyers on Thomasnet; only 3% look at more than ten</a:t>
             </a:r>
           </a:p>
         </p:txBody>
@@ -15315,7 +17847,7 @@
           <a:lstStyle/>
           <a:p>
             <a:r>
-              <a:t>Buyers rank favorites first, then reach out</a:t>
+              <a:t>B2B buyers across industries; favorites ranked before first contact</a:t>
             </a:r>
           </a:p>
         </p:txBody>
@@ -15357,7 +17889,7 @@
           <a:lstStyle/>
           <a:p>
             <a:r>
-              <a:t>Source: GlobalSpec / TREW Marketing, 2026 State of Marketing to Engineers (n=1,000+); Thomasnet Industrial Buyer Habits report; 6sense 2025 Buyer Experience Report (approx. 4,000 buyers).</a:t>
+              <a:t>Source: GlobalSpec / TREW Marketing, 2026 State of Marketing to Engineers (n=1,000+); Thomasnet Industrial Buyer Habits report; 6sense 2025 Buyer Experience Report (approx. 4,000 B2B buyers).</a:t>
             </a:r>
           </a:p>
         </p:txBody>
@@ -15515,7 +18047,7 @@
           <a:lstStyle/>
           <a:p>
             <a:r>
-              <a:t>Source: Thomasnet survey of 400+ registered industrial buyers (2021); Industrial Distribution Survey of Distributor Operations.</a:t>
+              <a:t>Source: Thomasnet survey of 400+ registered industrial buyers (2021); Industrial Distribution annual Survey of Distributor Operations.</a:t>
             </a:r>
           </a:p>
         </p:txBody>
@@ -15661,7 +18193,7 @@
               </a:spcAft>
             </a:pPr>
             <a:r>
-              <a:t>86% are more likely to buy when the company understands their goals.</a:t>
+              <a:t>Only 6% of technical buyers want no salesperson. They call for technical complexity (47%) and pricing or inventory (40%).</a:t>
             </a:r>
           </a:p>
           <a:p>
@@ -15671,7 +18203,7 @@
               </a:spcAft>
             </a:pPr>
             <a:r>
-              <a:t>84% expect the rep to act as a trusted advisor.</a:t>
+              <a:t>66% of engineers rate the vendor's engineering experts as highly trustworthy.</a:t>
             </a:r>
           </a:p>
           <a:p>
@@ -15681,7 +18213,7 @@
               </a:spcAft>
             </a:pPr>
             <a:r>
-              <a:t>Rep-assisted purchases carry half the regret of self-service buys: 21% vs 43%.</a:t>
+              <a:t>86% of business buyers are more likely to buy when the company understands their goals.</a:t>
             </a:r>
           </a:p>
           <a:p>
@@ -15691,7 +18223,7 @@
               </a:spcAft>
             </a:pPr>
             <a:r>
-              <a:t>Only 6% of technical buyers want no salesperson at all.</a:t>
+              <a:t>Rep-assisted purchases carry half the regret of self-service buys: 21% vs 43%.</a:t>
             </a:r>
           </a:p>
         </p:txBody>
@@ -15789,7 +18321,7 @@
           <a:lstStyle/>
           <a:p>
             <a:r>
-              <a:t>Source: Salesforce State of the Connected Customer 2023 (3,300 business buyers); Gartner B2B Buying Report (2022 survey, n=441); LinkedIn State of Sales 2021; Gartner 2025 sales survey via Salesforce.</a:t>
+              <a:t>Source: GlobalSpec / TREW 2025 and 2026 State of Marketing to Engineers; Salesforce State of the Connected Customer 2023 (3,300 business buyers); Gartner B2B Buying Report (2022 survey, n=441); LinkedIn State of Sales 2021.</a:t>
             </a:r>
           </a:p>
         </p:txBody>

</xml_diff>